<commit_message>
seminario: version final de la presentacion, 7 slides con cierre y correcciones de la revision
</commit_message>
<xml_diff>
--- a/sprint 20/seminario_avances.pptx
+++ b/sprint 20/seminario_avances.pptx
@@ -11,6 +11,7 @@
     <p:sldId id="259" r:id="rId10"/>
     <p:sldId id="260" r:id="rId11"/>
     <p:sldId id="261" r:id="rId12"/>
+    <p:sldId id="262" r:id="rId13"/>
   </p:sldIdLst>
   <p:sldSz cx="12191695" cy="6858000" type="screen4x3"/>
   <p:notesSz cx="6858000" cy="9144000"/>
@@ -3474,49 +3475,7 @@
       </p:sp>
       <p:sp>
         <p:nvSpPr>
-          <p:cNvPr id="4" name="TextBox 3"/>
-          <p:cNvSpPr txBox="1"/>
-          <p:nvPr/>
-        </p:nvSpPr>
-        <p:spPr>
-          <a:xfrm>
-            <a:off x="8229600" y="411480"/>
-            <a:ext cx="3429000" cy="457200"/>
-          </a:xfrm>
-          <a:prstGeom prst="rect">
-            <a:avLst/>
-          </a:prstGeom>
-          <a:noFill/>
-        </p:spPr>
-        <p:txBody>
-          <a:bodyPr wrap="square" anchor="t" lIns="25400" rIns="25400" tIns="12700" bIns="12700">
-            <a:spAutoFit/>
-          </a:bodyPr>
-          <a:lstStyle/>
-          <a:p>
-            <a:pPr algn="r">
-              <a:lnSpc>
-                <a:spcPct val="100000"/>
-              </a:lnSpc>
-              <a:spcAft>
-                <a:spcPts val="400"/>
-              </a:spcAft>
-            </a:pPr>
-            <a:r>
-              <a:rPr sz="1100" b="0">
-                <a:solidFill>
-                  <a:srgbClr val="6B6B6B"/>
-                </a:solidFill>
-                <a:latin typeface="Calibri"/>
-              </a:rPr>
-              <a:t>Investigación exploratoria y descriptiva · 12 meses</a:t>
-            </a:r>
-          </a:p>
-        </p:txBody>
-      </p:sp>
-      <p:sp>
-        <p:nvSpPr>
-          <p:cNvPr id="5" name="Rounded Rectangle 4"/>
+          <p:cNvPr id="4" name="Rounded Rectangle 3"/>
           <p:cNvSpPr/>
           <p:nvPr/>
         </p:nvSpPr>
@@ -3560,7 +3519,7 @@
       </p:sp>
       <p:sp>
         <p:nvSpPr>
-          <p:cNvPr id="6" name="TextBox 5"/>
+          <p:cNvPr id="5" name="TextBox 4"/>
           <p:cNvSpPr txBox="1"/>
           <p:nvPr/>
         </p:nvSpPr>
@@ -3602,7 +3561,7 @@
       </p:sp>
       <p:sp>
         <p:nvSpPr>
-          <p:cNvPr id="7" name="Rounded Rectangle 6"/>
+          <p:cNvPr id="6" name="Rounded Rectangle 5"/>
           <p:cNvSpPr/>
           <p:nvPr/>
         </p:nvSpPr>
@@ -3646,7 +3605,7 @@
       </p:sp>
       <p:sp>
         <p:nvSpPr>
-          <p:cNvPr id="8" name="TextBox 7"/>
+          <p:cNvPr id="7" name="TextBox 6"/>
           <p:cNvSpPr txBox="1"/>
           <p:nvPr/>
         </p:nvSpPr>
@@ -3688,7 +3647,7 @@
       </p:sp>
       <p:sp>
         <p:nvSpPr>
-          <p:cNvPr id="9" name="Left-Right Arrow 8"/>
+          <p:cNvPr id="8" name="Left-Right Arrow 7"/>
           <p:cNvSpPr/>
           <p:nvPr/>
         </p:nvSpPr>
@@ -3732,7 +3691,7 @@
       </p:sp>
       <p:sp>
         <p:nvSpPr>
-          <p:cNvPr id="10" name="Oval 9"/>
+          <p:cNvPr id="9" name="Oval 8"/>
           <p:cNvSpPr/>
           <p:nvPr/>
         </p:nvSpPr>
@@ -3776,7 +3735,7 @@
       </p:sp>
       <p:sp>
         <p:nvSpPr>
-          <p:cNvPr id="11" name="TextBox 10"/>
+          <p:cNvPr id="10" name="TextBox 9"/>
           <p:cNvSpPr txBox="1"/>
           <p:nvPr/>
         </p:nvSpPr>
@@ -3818,7 +3777,7 @@
       </p:sp>
       <p:sp>
         <p:nvSpPr>
-          <p:cNvPr id="12" name="Left-Right Arrow 11"/>
+          <p:cNvPr id="11" name="Left-Right Arrow 10"/>
           <p:cNvSpPr/>
           <p:nvPr/>
         </p:nvSpPr>
@@ -3862,7 +3821,7 @@
       </p:sp>
       <p:sp>
         <p:nvSpPr>
-          <p:cNvPr id="13" name="Rounded Rectangle 12"/>
+          <p:cNvPr id="12" name="Rounded Rectangle 11"/>
           <p:cNvSpPr/>
           <p:nvPr/>
         </p:nvSpPr>
@@ -3906,7 +3865,7 @@
       </p:sp>
       <p:sp>
         <p:nvSpPr>
-          <p:cNvPr id="14" name="TextBox 13"/>
+          <p:cNvPr id="13" name="TextBox 12"/>
           <p:cNvSpPr txBox="1"/>
           <p:nvPr/>
         </p:nvSpPr>
@@ -3948,14 +3907,14 @@
       </p:sp>
       <p:sp>
         <p:nvSpPr>
-          <p:cNvPr id="15" name="TextBox 14"/>
+          <p:cNvPr id="14" name="TextBox 13"/>
           <p:cNvSpPr txBox="1"/>
           <p:nvPr/>
         </p:nvSpPr>
         <p:spPr>
           <a:xfrm>
             <a:off x="640080" y="3886200"/>
-            <a:ext cx="7077456" cy="1463040"/>
+            <a:ext cx="7077456" cy="1737360"/>
           </a:xfrm>
           <a:prstGeom prst="rect">
             <a:avLst/>
@@ -3973,7 +3932,7 @@
                 <a:spcPct val="110000"/>
               </a:lnSpc>
               <a:spcAft>
-                <a:spcPts val="400"/>
+                <a:spcPts val="500"/>
               </a:spcAft>
             </a:pPr>
             <a:r>
@@ -3983,7 +3942,7 @@
                 </a:solidFill>
                 <a:latin typeface="Calibri"/>
               </a:rPr>
-              <a:t>La IAG se instala en el medio del intercambio.</a:t>
+              <a:t>El ciclo estudiado: el stakeholder declara qué necesita, el equipo construye y el mismo stakeholder valida lo construido.</a:t>
             </a:r>
           </a:p>
           <a:p>
@@ -3992,7 +3951,7 @@
                 <a:spcPct val="110000"/>
               </a:lnSpc>
               <a:spcAft>
-                <a:spcPts val="400"/>
+                <a:spcPts val="500"/>
               </a:spcAft>
             </a:pPr>
             <a:r>
@@ -4002,20 +3961,20 @@
                 </a:solidFill>
                 <a:latin typeface="Calibri"/>
               </a:rPr>
-              <a:t>El estudio describe qué cambia en ese ciclo: quién valida, cuándo y con qué granularidad.</a:t>
-            </a:r>
-          </a:p>
-        </p:txBody>
-      </p:sp>
-      <p:sp>
-        <p:nvSpPr>
-          <p:cNvPr id="16" name="TextBox 15"/>
+              <a:t>La IAG se instala en el medio de ese circuito; el estudio describe qué cambia.</a:t>
+            </a:r>
+          </a:p>
+        </p:txBody>
+      </p:sp>
+      <p:sp>
+        <p:nvSpPr>
+          <p:cNvPr id="15" name="TextBox 14"/>
           <p:cNvSpPr txBox="1"/>
           <p:nvPr/>
         </p:nvSpPr>
         <p:spPr>
           <a:xfrm>
-            <a:off x="8092440" y="2395728"/>
+            <a:off x="8092440" y="2286000"/>
             <a:ext cx="3657600" cy="365760"/>
           </a:xfrm>
           <a:prstGeom prst="rect">
@@ -4051,14 +4010,14 @@
       </p:sp>
       <p:sp>
         <p:nvSpPr>
-          <p:cNvPr id="17" name="TextBox 16"/>
+          <p:cNvPr id="16" name="TextBox 15"/>
           <p:cNvSpPr txBox="1"/>
           <p:nvPr/>
         </p:nvSpPr>
         <p:spPr>
           <a:xfrm>
-            <a:off x="8092440" y="2788920"/>
-            <a:ext cx="3657600" cy="3566160"/>
+            <a:off x="8092440" y="2679192"/>
+            <a:ext cx="3657600" cy="3657600"/>
           </a:xfrm>
           <a:prstGeom prst="rect">
             <a:avLst/>
@@ -4076,11 +4035,11 @@
                 <a:spcPct val="105000"/>
               </a:lnSpc>
               <a:spcAft>
-                <a:spcPts val="600"/>
-              </a:spcAft>
-            </a:pPr>
-            <a:r>
-              <a:rPr sz="1200" b="1">
+                <a:spcPts val="500"/>
+              </a:spcAft>
+            </a:pPr>
+            <a:r>
+              <a:rPr sz="1150" b="1">
                 <a:solidFill>
                   <a:srgbClr val="BF2026"/>
                 </a:solidFill>
@@ -4089,13 +4048,22 @@
               <a:t>▪ </a:t>
             </a:r>
             <a:r>
-              <a:rPr sz="1200" b="0">
+              <a:rPr sz="1150" b="1">
                 <a:solidFill>
                   <a:srgbClr val="363636"/>
                 </a:solidFill>
                 <a:latin typeface="Calibri"/>
               </a:rPr>
-              <a:t>Caracterizar las dinámicas de feedback técnico y de validación de negocio</a:t>
+              <a:t>Caracterizar </a:t>
+            </a:r>
+            <a:r>
+              <a:rPr sz="1150" b="0">
+                <a:solidFill>
+                  <a:srgbClr val="363636"/>
+                </a:solidFill>
+                <a:latin typeface="Calibri"/>
+              </a:rPr>
+              <a:t>las dinámicas actuales de feedback, como línea de base</a:t>
             </a:r>
           </a:p>
           <a:p>
@@ -4104,11 +4072,11 @@
                 <a:spcPct val="105000"/>
               </a:lnSpc>
               <a:spcAft>
-                <a:spcPts val="600"/>
-              </a:spcAft>
-            </a:pPr>
-            <a:r>
-              <a:rPr sz="1200" b="1">
+                <a:spcPts val="500"/>
+              </a:spcAft>
+            </a:pPr>
+            <a:r>
+              <a:rPr sz="1150" b="1">
                 <a:solidFill>
                   <a:srgbClr val="BF2026"/>
                 </a:solidFill>
@@ -4117,13 +4085,22 @@
               <a:t>▪ </a:t>
             </a:r>
             <a:r>
-              <a:rPr sz="1200" b="0">
+              <a:rPr sz="1150" b="1">
                 <a:solidFill>
                   <a:srgbClr val="363636"/>
                 </a:solidFill>
                 <a:latin typeface="Calibri"/>
               </a:rPr>
-              <a:t>Identificar cambios en frecuencia, granularidad y temporalidad</a:t>
+              <a:t>Identificar cambios </a:t>
+            </a:r>
+            <a:r>
+              <a:rPr sz="1150" b="0">
+                <a:solidFill>
+                  <a:srgbClr val="363636"/>
+                </a:solidFill>
+                <a:latin typeface="Calibri"/>
+              </a:rPr>
+              <a:t>en frecuencia, secuencia, granularidad y temporalidad</a:t>
             </a:r>
           </a:p>
           <a:p>
@@ -4132,11 +4109,11 @@
                 <a:spcPct val="105000"/>
               </a:lnSpc>
               <a:spcAft>
-                <a:spcPts val="600"/>
-              </a:spcAft>
-            </a:pPr>
-            <a:r>
-              <a:rPr sz="1200" b="1">
+                <a:spcPts val="500"/>
+              </a:spcAft>
+            </a:pPr>
+            <a:r>
+              <a:rPr sz="1150" b="1">
                 <a:solidFill>
                   <a:srgbClr val="BF2026"/>
                 </a:solidFill>
@@ -4145,13 +4122,22 @@
               <a:t>▪ </a:t>
             </a:r>
             <a:r>
-              <a:rPr sz="1200" b="0">
+              <a:rPr sz="1150" b="1">
                 <a:solidFill>
                   <a:srgbClr val="363636"/>
                 </a:solidFill>
                 <a:latin typeface="Calibri"/>
               </a:rPr>
-              <a:t>Examinar la transformación de roles: cliente, analista, equipo técnico</a:t>
+              <a:t>Examinar la transformación de roles: </a:t>
+            </a:r>
+            <a:r>
+              <a:rPr sz="1150" b="0">
+                <a:solidFill>
+                  <a:srgbClr val="363636"/>
+                </a:solidFill>
+                <a:latin typeface="Calibri"/>
+              </a:rPr>
+              <a:t>cliente, analista funcional, equipo</a:t>
             </a:r>
           </a:p>
           <a:p>
@@ -4160,11 +4146,11 @@
                 <a:spcPct val="105000"/>
               </a:lnSpc>
               <a:spcAft>
-                <a:spcPts val="600"/>
-              </a:spcAft>
-            </a:pPr>
-            <a:r>
-              <a:rPr sz="1200" b="1">
+                <a:spcPts val="500"/>
+              </a:spcAft>
+            </a:pPr>
+            <a:r>
+              <a:rPr sz="1150" b="1">
                 <a:solidFill>
                   <a:srgbClr val="BF2026"/>
                 </a:solidFill>
@@ -4173,13 +4159,22 @@
               <a:t>▪ </a:t>
             </a:r>
             <a:r>
-              <a:rPr sz="1200" b="0">
+              <a:rPr sz="1150" b="1">
                 <a:solidFill>
                   <a:srgbClr val="363636"/>
                 </a:solidFill>
                 <a:latin typeface="Calibri"/>
               </a:rPr>
-              <a:t>Analizar la validación temprana de reglas y flujos de negocio</a:t>
+              <a:t>Analizar la validación temprana </a:t>
+            </a:r>
+            <a:r>
+              <a:rPr sz="1150" b="0">
+                <a:solidFill>
+                  <a:srgbClr val="363636"/>
+                </a:solidFill>
+                <a:latin typeface="Calibri"/>
+              </a:rPr>
+              <a:t>de reglas y flujos de negocio</a:t>
             </a:r>
           </a:p>
           <a:p>
@@ -4188,11 +4183,11 @@
                 <a:spcPct val="105000"/>
               </a:lnSpc>
               <a:spcAft>
-                <a:spcPts val="600"/>
-              </a:spcAft>
-            </a:pPr>
-            <a:r>
-              <a:rPr sz="1200" b="1">
+                <a:spcPts val="500"/>
+              </a:spcAft>
+            </a:pPr>
+            <a:r>
+              <a:rPr sz="1150" b="1">
                 <a:solidFill>
                   <a:srgbClr val="BF2026"/>
                 </a:solidFill>
@@ -4201,20 +4196,66 @@
               <a:t>▪ </a:t>
             </a:r>
             <a:r>
-              <a:rPr sz="1200" b="0">
+              <a:rPr sz="1150" b="1">
                 <a:solidFill>
                   <a:srgbClr val="363636"/>
                 </a:solidFill>
                 <a:latin typeface="Calibri"/>
               </a:rPr>
-              <a:t>Desarrollar una PoC para usuarios no técnicos</a:t>
-            </a:r>
-          </a:p>
-        </p:txBody>
-      </p:sp>
-      <p:sp>
-        <p:nvSpPr>
-          <p:cNvPr id="18" name="Rounded Rectangle 17"/>
+              <a:t>Describir los efectos </a:t>
+            </a:r>
+            <a:r>
+              <a:rPr sz="1150" b="0">
+                <a:solidFill>
+                  <a:srgbClr val="363636"/>
+                </a:solidFill>
+                <a:latin typeface="Calibri"/>
+              </a:rPr>
+              <a:t>reportados por la literatura relevada</a:t>
+            </a:r>
+          </a:p>
+          <a:p>
+            <a:pPr algn="l">
+              <a:lnSpc>
+                <a:spcPct val="105000"/>
+              </a:lnSpc>
+              <a:spcAft>
+                <a:spcPts val="500"/>
+              </a:spcAft>
+            </a:pPr>
+            <a:r>
+              <a:rPr sz="1150" b="1">
+                <a:solidFill>
+                  <a:srgbClr val="BF2026"/>
+                </a:solidFill>
+                <a:latin typeface="Calibri"/>
+              </a:rPr>
+              <a:t>▪ </a:t>
+            </a:r>
+            <a:r>
+              <a:rPr sz="1150" b="1">
+                <a:solidFill>
+                  <a:srgbClr val="363636"/>
+                </a:solidFill>
+                <a:latin typeface="Calibri"/>
+              </a:rPr>
+              <a:t>Desarrollar una PoC </a:t>
+            </a:r>
+            <a:r>
+              <a:rPr sz="1150" b="0">
+                <a:solidFill>
+                  <a:srgbClr val="363636"/>
+                </a:solidFill>
+                <a:latin typeface="Calibri"/>
+              </a:rPr>
+              <a:t>exploratoria para usuarios no técnicos</a:t>
+            </a:r>
+          </a:p>
+        </p:txBody>
+      </p:sp>
+      <p:sp>
+        <p:nvSpPr>
+          <p:cNvPr id="17" name="Rounded Rectangle 16"/>
           <p:cNvSpPr/>
           <p:nvPr/>
         </p:nvSpPr>
@@ -4258,7 +4299,7 @@
       </p:sp>
       <p:sp>
         <p:nvSpPr>
-          <p:cNvPr id="19" name="TextBox 18"/>
+          <p:cNvPr id="18" name="TextBox 17"/>
           <p:cNvSpPr txBox="1"/>
           <p:nvPr/>
         </p:nvSpPr>
@@ -4293,7 +4334,7 @@
                 </a:solidFill>
                 <a:latin typeface="Calibri"/>
               </a:rPr>
-              <a:t>Dos dimensiones integradas: feedback técnico y validación de reglas y flujos de negocio</a:t>
+              <a:t>Alcance: feedback durante el desarrollo iterativo y aceptación sobre software ya construido</a:t>
             </a:r>
           </a:p>
         </p:txBody>
@@ -4404,49 +4445,7 @@
       </p:sp>
       <p:sp>
         <p:nvSpPr>
-          <p:cNvPr id="4" name="TextBox 3"/>
-          <p:cNvSpPr txBox="1"/>
-          <p:nvPr/>
-        </p:nvSpPr>
-        <p:spPr>
-          <a:xfrm>
-            <a:off x="8229600" y="411480"/>
-            <a:ext cx="3429000" cy="457200"/>
-          </a:xfrm>
-          <a:prstGeom prst="rect">
-            <a:avLst/>
-          </a:prstGeom>
-          <a:noFill/>
-        </p:spPr>
-        <p:txBody>
-          <a:bodyPr wrap="square" anchor="t" lIns="25400" rIns="25400" tIns="12700" bIns="12700">
-            <a:spAutoFit/>
-          </a:bodyPr>
-          <a:lstStyle/>
-          <a:p>
-            <a:pPr algn="r">
-              <a:lnSpc>
-                <a:spcPct val="100000"/>
-              </a:lnSpc>
-              <a:spcAft>
-                <a:spcPts val="400"/>
-              </a:spcAft>
-            </a:pPr>
-            <a:r>
-              <a:rPr sz="1100" b="0">
-                <a:solidFill>
-                  <a:srgbClr val="6B6B6B"/>
-                </a:solidFill>
-                <a:latin typeface="Calibri"/>
-              </a:rPr>
-              <a:t>Febrero · octubre 2026 · 20 sprints</a:t>
-            </a:r>
-          </a:p>
-        </p:txBody>
-      </p:sp>
-      <p:sp>
-        <p:nvSpPr>
-          <p:cNvPr id="5" name="Chevron 4"/>
+          <p:cNvPr id="4" name="Chevron 3"/>
           <p:cNvSpPr/>
           <p:nvPr/>
         </p:nvSpPr>
@@ -4490,7 +4489,7 @@
       </p:sp>
       <p:sp>
         <p:nvSpPr>
-          <p:cNvPr id="6" name="TextBox 5"/>
+          <p:cNvPr id="5" name="TextBox 4"/>
           <p:cNvSpPr txBox="1"/>
           <p:nvPr/>
         </p:nvSpPr>
@@ -4532,7 +4531,7 @@
       </p:sp>
       <p:sp>
         <p:nvSpPr>
-          <p:cNvPr id="7" name="TextBox 6"/>
+          <p:cNvPr id="6" name="TextBox 5"/>
           <p:cNvSpPr txBox="1"/>
           <p:nvPr/>
         </p:nvSpPr>
@@ -4574,7 +4573,7 @@
       </p:sp>
       <p:sp>
         <p:nvSpPr>
-          <p:cNvPr id="8" name="TextBox 7"/>
+          <p:cNvPr id="7" name="TextBox 6"/>
           <p:cNvSpPr txBox="1"/>
           <p:nvPr/>
         </p:nvSpPr>
@@ -4681,7 +4680,7 @@
       </p:sp>
       <p:sp>
         <p:nvSpPr>
-          <p:cNvPr id="9" name="Chevron 8"/>
+          <p:cNvPr id="8" name="Chevron 7"/>
           <p:cNvSpPr/>
           <p:nvPr/>
         </p:nvSpPr>
@@ -4725,7 +4724,7 @@
       </p:sp>
       <p:sp>
         <p:nvSpPr>
-          <p:cNvPr id="10" name="TextBox 9"/>
+          <p:cNvPr id="9" name="TextBox 8"/>
           <p:cNvSpPr txBox="1"/>
           <p:nvPr/>
         </p:nvSpPr>
@@ -4767,7 +4766,7 @@
       </p:sp>
       <p:sp>
         <p:nvSpPr>
-          <p:cNvPr id="11" name="TextBox 10"/>
+          <p:cNvPr id="10" name="TextBox 9"/>
           <p:cNvSpPr txBox="1"/>
           <p:nvPr/>
         </p:nvSpPr>
@@ -4809,7 +4808,7 @@
       </p:sp>
       <p:sp>
         <p:nvSpPr>
-          <p:cNvPr id="12" name="TextBox 11"/>
+          <p:cNvPr id="11" name="TextBox 10"/>
           <p:cNvSpPr txBox="1"/>
           <p:nvPr/>
         </p:nvSpPr>
@@ -4916,7 +4915,7 @@
       </p:sp>
       <p:sp>
         <p:nvSpPr>
-          <p:cNvPr id="13" name="Chevron 12"/>
+          <p:cNvPr id="12" name="Chevron 11"/>
           <p:cNvSpPr/>
           <p:nvPr/>
         </p:nvSpPr>
@@ -4960,7 +4959,7 @@
       </p:sp>
       <p:sp>
         <p:nvSpPr>
-          <p:cNvPr id="14" name="TextBox 13"/>
+          <p:cNvPr id="13" name="TextBox 12"/>
           <p:cNvSpPr txBox="1"/>
           <p:nvPr/>
         </p:nvSpPr>
@@ -5002,7 +5001,7 @@
       </p:sp>
       <p:sp>
         <p:nvSpPr>
-          <p:cNvPr id="15" name="TextBox 14"/>
+          <p:cNvPr id="14" name="TextBox 13"/>
           <p:cNvSpPr txBox="1"/>
           <p:nvPr/>
         </p:nvSpPr>
@@ -5044,7 +5043,7 @@
       </p:sp>
       <p:sp>
         <p:nvSpPr>
-          <p:cNvPr id="16" name="TextBox 15"/>
+          <p:cNvPr id="15" name="TextBox 14"/>
           <p:cNvSpPr txBox="1"/>
           <p:nvPr/>
         </p:nvSpPr>
@@ -5116,7 +5115,7 @@
                 </a:solidFill>
                 <a:latin typeface="Calibri"/>
               </a:rPr>
-              <a:t>7 categorías · escenarios S1-S4</a:t>
+              <a:t>Cómo la IAG altera el ciclo de feedback</a:t>
             </a:r>
           </a:p>
           <a:p>
@@ -5151,7 +5150,7 @@
       </p:sp>
       <p:sp>
         <p:nvSpPr>
-          <p:cNvPr id="17" name="Chevron 16"/>
+          <p:cNvPr id="16" name="Chevron 15"/>
           <p:cNvSpPr/>
           <p:nvPr/>
         </p:nvSpPr>
@@ -5195,7 +5194,7 @@
       </p:sp>
       <p:sp>
         <p:nvSpPr>
-          <p:cNvPr id="18" name="TextBox 17"/>
+          <p:cNvPr id="17" name="TextBox 16"/>
           <p:cNvSpPr txBox="1"/>
           <p:nvPr/>
         </p:nvSpPr>
@@ -5237,7 +5236,7 @@
       </p:sp>
       <p:sp>
         <p:nvSpPr>
-          <p:cNvPr id="19" name="TextBox 18"/>
+          <p:cNvPr id="18" name="TextBox 17"/>
           <p:cNvSpPr txBox="1"/>
           <p:nvPr/>
         </p:nvSpPr>
@@ -5272,14 +5271,14 @@
                 </a:solidFill>
                 <a:latin typeface="Calibri"/>
               </a:rPr>
-              <a:t>Redacción de la memoria</a:t>
-            </a:r>
-          </a:p>
-        </p:txBody>
-      </p:sp>
-      <p:sp>
-        <p:nvSpPr>
-          <p:cNvPr id="20" name="TextBox 19"/>
+              <a:t>Documento de tesis (Overleaf)</a:t>
+            </a:r>
+          </a:p>
+        </p:txBody>
+      </p:sp>
+      <p:sp>
+        <p:nvSpPr>
+          <p:cNvPr id="19" name="TextBox 18"/>
           <p:cNvSpPr txBox="1"/>
           <p:nvPr/>
         </p:nvSpPr>
@@ -5323,7 +5322,7 @@
                 </a:solidFill>
                 <a:latin typeface="Calibri"/>
               </a:rPr>
-              <a:t>Índice aprobado</a:t>
+              <a:t>Índice aprobado con el tutor</a:t>
             </a:r>
           </a:p>
           <a:p>
@@ -5386,7 +5385,7 @@
       </p:sp>
       <p:sp>
         <p:nvSpPr>
-          <p:cNvPr id="21" name="Chevron 20"/>
+          <p:cNvPr id="20" name="Chevron 19"/>
           <p:cNvSpPr/>
           <p:nvPr/>
         </p:nvSpPr>
@@ -5430,7 +5429,7 @@
       </p:sp>
       <p:sp>
         <p:nvSpPr>
-          <p:cNvPr id="22" name="TextBox 21"/>
+          <p:cNvPr id="21" name="TextBox 20"/>
           <p:cNvSpPr txBox="1"/>
           <p:nvPr/>
         </p:nvSpPr>
@@ -5472,7 +5471,7 @@
       </p:sp>
       <p:sp>
         <p:nvSpPr>
-          <p:cNvPr id="23" name="TextBox 22"/>
+          <p:cNvPr id="22" name="TextBox 21"/>
           <p:cNvSpPr txBox="1"/>
           <p:nvPr/>
         </p:nvSpPr>
@@ -5514,7 +5513,7 @@
       </p:sp>
       <p:sp>
         <p:nvSpPr>
-          <p:cNvPr id="24" name="TextBox 23"/>
+          <p:cNvPr id="23" name="TextBox 22"/>
           <p:cNvSpPr txBox="1"/>
           <p:nvPr/>
         </p:nvSpPr>
@@ -5621,7 +5620,7 @@
       </p:sp>
       <p:sp>
         <p:nvSpPr>
-          <p:cNvPr id="25" name="Rounded Rectangle 24"/>
+          <p:cNvPr id="24" name="Rounded Rectangle 23"/>
           <p:cNvSpPr/>
           <p:nvPr/>
         </p:nvSpPr>
@@ -5665,7 +5664,7 @@
       </p:sp>
       <p:sp>
         <p:nvSpPr>
-          <p:cNvPr id="26" name="TextBox 25"/>
+          <p:cNvPr id="25" name="TextBox 24"/>
           <p:cNvSpPr txBox="1"/>
           <p:nvPr/>
         </p:nvSpPr>
@@ -5707,7 +5706,7 @@
       </p:sp>
       <p:sp>
         <p:nvSpPr>
-          <p:cNvPr id="27" name="TextBox 26"/>
+          <p:cNvPr id="26" name="TextBox 25"/>
           <p:cNvSpPr txBox="1"/>
           <p:nvPr/>
         </p:nvSpPr>
@@ -5749,7 +5748,7 @@
       </p:sp>
       <p:sp>
         <p:nvSpPr>
-          <p:cNvPr id="28" name="TextBox 27"/>
+          <p:cNvPr id="27" name="TextBox 26"/>
           <p:cNvSpPr txBox="1"/>
           <p:nvPr/>
         </p:nvSpPr>
@@ -5791,7 +5790,7 @@
       </p:sp>
       <p:sp>
         <p:nvSpPr>
-          <p:cNvPr id="29" name="TextBox 28"/>
+          <p:cNvPr id="28" name="TextBox 27"/>
           <p:cNvSpPr txBox="1"/>
           <p:nvPr/>
         </p:nvSpPr>
@@ -5833,7 +5832,7 @@
       </p:sp>
       <p:sp>
         <p:nvSpPr>
-          <p:cNvPr id="30" name="TextBox 29"/>
+          <p:cNvPr id="29" name="TextBox 28"/>
           <p:cNvSpPr txBox="1"/>
           <p:nvPr/>
         </p:nvSpPr>
@@ -5875,7 +5874,7 @@
       </p:sp>
       <p:sp>
         <p:nvSpPr>
-          <p:cNvPr id="31" name="TextBox 30"/>
+          <p:cNvPr id="30" name="TextBox 29"/>
           <p:cNvSpPr txBox="1"/>
           <p:nvPr/>
         </p:nvSpPr>
@@ -5917,7 +5916,7 @@
       </p:sp>
       <p:sp>
         <p:nvSpPr>
-          <p:cNvPr id="32" name="TextBox 31"/>
+          <p:cNvPr id="31" name="TextBox 30"/>
           <p:cNvSpPr txBox="1"/>
           <p:nvPr/>
         </p:nvSpPr>
@@ -5959,7 +5958,7 @@
       </p:sp>
       <p:sp>
         <p:nvSpPr>
-          <p:cNvPr id="33" name="TextBox 32"/>
+          <p:cNvPr id="32" name="TextBox 31"/>
           <p:cNvSpPr txBox="1"/>
           <p:nvPr/>
         </p:nvSpPr>
@@ -6001,7 +6000,7 @@
       </p:sp>
       <p:sp>
         <p:nvSpPr>
-          <p:cNvPr id="34" name="TextBox 33"/>
+          <p:cNvPr id="33" name="TextBox 32"/>
           <p:cNvSpPr txBox="1"/>
           <p:nvPr/>
         </p:nvSpPr>
@@ -6043,7 +6042,7 @@
       </p:sp>
       <p:sp>
         <p:nvSpPr>
-          <p:cNvPr id="35" name="TextBox 34"/>
+          <p:cNvPr id="34" name="TextBox 33"/>
           <p:cNvSpPr txBox="1"/>
           <p:nvPr/>
         </p:nvSpPr>
@@ -6195,8 +6194,8 @@
         </p:nvSpPr>
         <p:spPr>
           <a:xfrm>
-            <a:off x="8229600" y="411480"/>
-            <a:ext cx="3429000" cy="457200"/>
+            <a:off x="502920" y="1188720"/>
+            <a:ext cx="5486400" cy="365760"/>
           </a:xfrm>
           <a:prstGeom prst="rect">
             <a:avLst/>
@@ -6209,7 +6208,7 @@
           </a:bodyPr>
           <a:lstStyle/>
           <a:p>
-            <a:pPr algn="r">
+            <a:pPr algn="l">
               <a:lnSpc>
                 <a:spcPct val="100000"/>
               </a:lnSpc>
@@ -6218,13 +6217,13 @@
               </a:spcAft>
             </a:pPr>
             <a:r>
-              <a:rPr sz="1100" b="0">
-                <a:solidFill>
-                  <a:srgbClr val="6B6B6B"/>
-                </a:solidFill>
-                <a:latin typeface="Calibri"/>
-              </a:rPr>
-              <a:t>Mes 8 de 12 · sprint 20</a:t>
+              <a:rPr sz="1500" b="1">
+                <a:solidFill>
+                  <a:srgbClr val="661020"/>
+                </a:solidFill>
+                <a:latin typeface="Calibri"/>
+              </a:rPr>
+              <a:t>Resultados a la fecha</a:t>
             </a:r>
           </a:p>
         </p:txBody>
@@ -6237,8 +6236,8 @@
         </p:nvSpPr>
         <p:spPr>
           <a:xfrm>
-            <a:off x="502920" y="1188720"/>
-            <a:ext cx="5486400" cy="365760"/>
+            <a:off x="502920" y="1600200"/>
+            <a:ext cx="5486400" cy="2286000"/>
           </a:xfrm>
           <a:prstGeom prst="rect">
             <a:avLst/>
@@ -6253,20 +6252,112 @@
           <a:p>
             <a:pPr algn="l">
               <a:lnSpc>
-                <a:spcPct val="100000"/>
-              </a:lnSpc>
-              <a:spcAft>
-                <a:spcPts val="400"/>
-              </a:spcAft>
-            </a:pPr>
-            <a:r>
-              <a:rPr sz="1500" b="1">
-                <a:solidFill>
-                  <a:srgbClr val="661020"/>
-                </a:solidFill>
-                <a:latin typeface="Calibri"/>
-              </a:rPr>
-              <a:t>Resultados a la fecha</a:t>
+                <a:spcPct val="105000"/>
+              </a:lnSpc>
+              <a:spcAft>
+                <a:spcPts val="800"/>
+              </a:spcAft>
+            </a:pPr>
+            <a:r>
+              <a:rPr sz="1250" b="1">
+                <a:solidFill>
+                  <a:srgbClr val="BF2026"/>
+                </a:solidFill>
+                <a:latin typeface="Calibri"/>
+              </a:rPr>
+              <a:t>▪ </a:t>
+            </a:r>
+            <a:r>
+              <a:rPr sz="1250" b="1">
+                <a:solidFill>
+                  <a:srgbClr val="363636"/>
+                </a:solidFill>
+                <a:latin typeface="Calibri"/>
+              </a:rPr>
+              <a:t>Marco conceptual propio cerrado: </a:t>
+            </a:r>
+            <a:r>
+              <a:rPr sz="1250" b="0">
+                <a:solidFill>
+                  <a:srgbClr val="363636"/>
+                </a:solidFill>
+                <a:latin typeface="Calibri"/>
+              </a:rPr>
+              <a:t>describe el ciclo de feedback y cómo la IAG lo reconfigura</a:t>
+            </a:r>
+          </a:p>
+          <a:p>
+            <a:pPr algn="l">
+              <a:lnSpc>
+                <a:spcPct val="105000"/>
+              </a:lnSpc>
+              <a:spcAft>
+                <a:spcPts val="800"/>
+              </a:spcAft>
+            </a:pPr>
+            <a:r>
+              <a:rPr sz="1250" b="1">
+                <a:solidFill>
+                  <a:srgbClr val="BF2026"/>
+                </a:solidFill>
+                <a:latin typeface="Calibri"/>
+              </a:rPr>
+              <a:t>▪ </a:t>
+            </a:r>
+            <a:r>
+              <a:rPr sz="1250" b="1">
+                <a:solidFill>
+                  <a:srgbClr val="363636"/>
+                </a:solidFill>
+                <a:latin typeface="Calibri"/>
+              </a:rPr>
+              <a:t>Revisión bibliográfica integrada al documento, </a:t>
+            </a:r>
+            <a:r>
+              <a:rPr sz="1250" b="0">
+                <a:solidFill>
+                  <a:srgbClr val="363636"/>
+                </a:solidFill>
+                <a:latin typeface="Calibri"/>
+              </a:rPr>
+              <a:t>con la vía de entrada de cada trabajo trazada</a:t>
+            </a:r>
+          </a:p>
+          <a:p>
+            <a:pPr algn="l">
+              <a:lnSpc>
+                <a:spcPct val="105000"/>
+              </a:lnSpc>
+              <a:spcAft>
+                <a:spcPts val="800"/>
+              </a:spcAft>
+            </a:pPr>
+            <a:r>
+              <a:rPr sz="1250" b="1">
+                <a:solidFill>
+                  <a:srgbClr val="BF2026"/>
+                </a:solidFill>
+                <a:latin typeface="Calibri"/>
+              </a:rPr>
+              <a:t>▪ </a:t>
+            </a:r>
+            <a:r>
+              <a:rPr sz="1250" b="1">
+                <a:solidFill>
+                  <a:srgbClr val="363636"/>
+                </a:solidFill>
+                <a:latin typeface="Calibri"/>
+              </a:rPr>
+              <a:t>Documento de tesis en redacción: </a:t>
+            </a:r>
+            <a:r>
+              <a:rPr sz="1250" b="0">
+                <a:solidFill>
+                  <a:srgbClr val="363636"/>
+                </a:solidFill>
+                <a:latin typeface="Calibri"/>
+              </a:rPr>
+              <a:t>introducción, background y capítulo central escritos</a:t>
             </a:r>
           </a:p>
         </p:txBody>
@@ -6279,8 +6370,8 @@
         </p:nvSpPr>
         <p:spPr>
           <a:xfrm>
-            <a:off x="502920" y="1600200"/>
-            <a:ext cx="5486400" cy="2103120"/>
+            <a:off x="6492240" y="1188720"/>
+            <a:ext cx="5212080" cy="365760"/>
           </a:xfrm>
           <a:prstGeom prst="rect">
             <a:avLst/>
@@ -6295,6 +6386,48 @@
           <a:p>
             <a:pPr algn="l">
               <a:lnSpc>
+                <a:spcPct val="100000"/>
+              </a:lnSpc>
+              <a:spcAft>
+                <a:spcPts val="400"/>
+              </a:spcAft>
+            </a:pPr>
+            <a:r>
+              <a:rPr sz="1500" b="1">
+                <a:solidFill>
+                  <a:srgbClr val="661020"/>
+                </a:solidFill>
+                <a:latin typeface="Calibri"/>
+              </a:rPr>
+              <a:t>Dónde estamos hoy</a:t>
+            </a:r>
+          </a:p>
+        </p:txBody>
+      </p:sp>
+      <p:sp>
+        <p:nvSpPr>
+          <p:cNvPr id="7" name="TextBox 6"/>
+          <p:cNvSpPr txBox="1"/>
+          <p:nvPr/>
+        </p:nvSpPr>
+        <p:spPr>
+          <a:xfrm>
+            <a:off x="6492240" y="1600200"/>
+            <a:ext cx="5212080" cy="2286000"/>
+          </a:xfrm>
+          <a:prstGeom prst="rect">
+            <a:avLst/>
+          </a:prstGeom>
+          <a:noFill/>
+        </p:spPr>
+        <p:txBody>
+          <a:bodyPr wrap="square" anchor="t" lIns="25400" rIns="25400" tIns="12700" bIns="12700">
+            <a:spAutoFit/>
+          </a:bodyPr>
+          <a:lstStyle/>
+          <a:p>
+            <a:pPr algn="l">
+              <a:lnSpc>
                 <a:spcPct val="105000"/>
               </a:lnSpc>
               <a:spcAft>
@@ -6317,7 +6450,7 @@
                 </a:solidFill>
                 <a:latin typeface="Calibri"/>
               </a:rPr>
-              <a:t>Marco conceptual propio cerrado: </a:t>
+              <a:t>Prototipo definido y en implementación: </a:t>
             </a:r>
             <a:r>
               <a:rPr sz="1250" b="0">
@@ -6326,7 +6459,7 @@
                 </a:solidFill>
                 <a:latin typeface="Calibri"/>
               </a:rPr>
-              <a:t>proceso de feedback con IAG, 7 categorías, escenarios S1-S4</a:t>
+              <a:t>asistente de sesiones de feedback</a:t>
             </a:r>
           </a:p>
           <a:p>
@@ -6354,7 +6487,7 @@
                 </a:solidFill>
                 <a:latin typeface="Calibri"/>
               </a:rPr>
-              <a:t>Revisión bibliográfica integrada a la memoria: </a:t>
+              <a:t>Ajuste metodológico acordado: </a:t>
             </a:r>
             <a:r>
               <a:rPr sz="1250" b="0">
@@ -6363,7 +6496,7 @@
                 </a:solidFill>
                 <a:latin typeface="Calibri"/>
               </a:rPr>
-              <a:t>18 trabajos, todos con origen trazado</a:t>
+              <a:t>sin entrevistas; la PoC es la instancia de observación directa</a:t>
             </a:r>
           </a:p>
           <a:p>
@@ -6391,7 +6524,7 @@
                 </a:solidFill>
                 <a:latin typeface="Calibri"/>
               </a:rPr>
-              <a:t>Memoria en redacción: </a:t>
+              <a:t>Revisión presentada como bibliográfica, </a:t>
             </a:r>
             <a:r>
               <a:rPr sz="1250" b="0">
@@ -6400,21 +6533,21 @@
                 </a:solidFill>
                 <a:latin typeface="Calibri"/>
               </a:rPr>
-              <a:t>introducción, background y capítulo central escritos</a:t>
-            </a:r>
-          </a:p>
-        </p:txBody>
-      </p:sp>
-      <p:sp>
-        <p:nvSpPr>
-          <p:cNvPr id="7" name="Rounded Rectangle 6"/>
+              <a:t>no como revisión sistemática</a:t>
+            </a:r>
+          </a:p>
+        </p:txBody>
+      </p:sp>
+      <p:sp>
+        <p:nvSpPr>
+          <p:cNvPr id="8" name="Rounded Rectangle 7"/>
           <p:cNvSpPr/>
           <p:nvPr/>
         </p:nvSpPr>
         <p:spPr>
           <a:xfrm>
-            <a:off x="502920" y="3794760"/>
-            <a:ext cx="5486400" cy="2103120"/>
+            <a:off x="502920" y="3657600"/>
+            <a:ext cx="11201400" cy="2103120"/>
           </a:xfrm>
           <a:prstGeom prst="roundRect">
             <a:avLst/>
@@ -6451,14 +6584,14 @@
       </p:sp>
       <p:sp>
         <p:nvSpPr>
-          <p:cNvPr id="8" name="TextBox 7"/>
+          <p:cNvPr id="9" name="TextBox 8"/>
           <p:cNvSpPr txBox="1"/>
           <p:nvPr/>
         </p:nvSpPr>
         <p:spPr>
           <a:xfrm>
-            <a:off x="777240" y="4005072"/>
-            <a:ext cx="4983480" cy="457200"/>
+            <a:off x="777240" y="3840480"/>
+            <a:ext cx="10698480" cy="457200"/>
           </a:xfrm>
           <a:prstGeom prst="rect">
             <a:avLst/>
@@ -6486,21 +6619,21 @@
                 </a:solidFill>
                 <a:latin typeface="Calibri"/>
               </a:rPr>
-              <a:t>Hallazgo: doble vacío en la literatura</a:t>
-            </a:r>
-          </a:p>
-        </p:txBody>
-      </p:sp>
-      <p:sp>
-        <p:nvSpPr>
-          <p:cNvPr id="9" name="TextBox 8"/>
+              <a:t>Aspectos que el relevamiento deja planteados</a:t>
+            </a:r>
+          </a:p>
+        </p:txBody>
+      </p:sp>
+      <p:sp>
+        <p:nvSpPr>
+          <p:cNvPr id="10" name="TextBox 9"/>
           <p:cNvSpPr txBox="1"/>
           <p:nvPr/>
         </p:nvSpPr>
         <p:spPr>
           <a:xfrm>
-            <a:off x="777240" y="4526280"/>
-            <a:ext cx="4983480" cy="1371600"/>
+            <a:off x="777240" y="4343400"/>
+            <a:ext cx="10698480" cy="1325880"/>
           </a:xfrm>
           <a:prstGeom prst="rect">
             <a:avLst/>
@@ -6518,7 +6651,7 @@
                 <a:spcPct val="110000"/>
               </a:lnSpc>
               <a:spcAft>
-                <a:spcPts val="800"/>
+                <a:spcPts val="700"/>
               </a:spcAft>
             </a:pPr>
             <a:r>
@@ -6537,7 +6670,7 @@
                 </a:solidFill>
                 <a:latin typeface="Calibri"/>
               </a:rPr>
-              <a:t>No hay estudios de la validación del stakeholder sobre software ya construido</a:t>
+              <a:t>Lo relevado se concentra en etapas tempranas y en herramientas que asisten al equipo de desarrollo</a:t>
             </a:r>
           </a:p>
           <a:p>
@@ -6546,7 +6679,7 @@
                 <a:spcPct val="110000"/>
               </a:lnSpc>
               <a:spcAft>
-                <a:spcPts val="800"/>
+                <a:spcPts val="700"/>
               </a:spcAft>
             </a:pPr>
             <a:r>
@@ -6565,7 +6698,7 @@
                 </a:solidFill>
                 <a:latin typeface="Calibri"/>
               </a:rPr>
-              <a:t>Tampoco de la validación de lo construido contra reglas y flujos de negocio</a:t>
+              <a:t>En lo relevado no se encontró evidencia empírica de la aceptación del stakeholder sobre software ya construido, ni de la validación de lo construido contra reglas y flujos de negocio</a:t>
             </a:r>
           </a:p>
           <a:p>
@@ -6574,7 +6707,7 @@
                 <a:spcPct val="110000"/>
               </a:lnSpc>
               <a:spcAft>
-                <a:spcPts val="800"/>
+                <a:spcPts val="700"/>
               </a:spcAft>
             </a:pPr>
             <a:r>
@@ -6584,306 +6717,7 @@
                 </a:solidFill>
                 <a:latin typeface="Calibri"/>
               </a:rPr>
-              <a:t>La PoC de la tesis apunta exactamente a ese vacío.</a:t>
-            </a:r>
-          </a:p>
-        </p:txBody>
-      </p:sp>
-      <p:sp>
-        <p:nvSpPr>
-          <p:cNvPr id="10" name="TextBox 9"/>
-          <p:cNvSpPr txBox="1"/>
-          <p:nvPr/>
-        </p:nvSpPr>
-        <p:spPr>
-          <a:xfrm>
-            <a:off x="6492240" y="1188720"/>
-            <a:ext cx="5212080" cy="365760"/>
-          </a:xfrm>
-          <a:prstGeom prst="rect">
-            <a:avLst/>
-          </a:prstGeom>
-          <a:noFill/>
-        </p:spPr>
-        <p:txBody>
-          <a:bodyPr wrap="square" anchor="t" lIns="25400" rIns="25400" tIns="12700" bIns="12700">
-            <a:spAutoFit/>
-          </a:bodyPr>
-          <a:lstStyle/>
-          <a:p>
-            <a:pPr algn="l">
-              <a:lnSpc>
-                <a:spcPct val="100000"/>
-              </a:lnSpc>
-              <a:spcAft>
-                <a:spcPts val="400"/>
-              </a:spcAft>
-            </a:pPr>
-            <a:r>
-              <a:rPr sz="1500" b="1">
-                <a:solidFill>
-                  <a:srgbClr val="661020"/>
-                </a:solidFill>
-                <a:latin typeface="Calibri"/>
-              </a:rPr>
-              <a:t>Dónde estamos hoy</a:t>
-            </a:r>
-          </a:p>
-        </p:txBody>
-      </p:sp>
-      <p:sp>
-        <p:nvSpPr>
-          <p:cNvPr id="11" name="TextBox 10"/>
-          <p:cNvSpPr txBox="1"/>
-          <p:nvPr/>
-        </p:nvSpPr>
-        <p:spPr>
-          <a:xfrm>
-            <a:off x="6492240" y="1600200"/>
-            <a:ext cx="5212080" cy="2926080"/>
-          </a:xfrm>
-          <a:prstGeom prst="rect">
-            <a:avLst/>
-          </a:prstGeom>
-          <a:noFill/>
-        </p:spPr>
-        <p:txBody>
-          <a:bodyPr wrap="square" anchor="t" lIns="25400" rIns="25400" tIns="12700" bIns="12700">
-            <a:spAutoFit/>
-          </a:bodyPr>
-          <a:lstStyle/>
-          <a:p>
-            <a:pPr algn="l">
-              <a:lnSpc>
-                <a:spcPct val="105000"/>
-              </a:lnSpc>
-              <a:spcAft>
-                <a:spcPts val="800"/>
-              </a:spcAft>
-            </a:pPr>
-            <a:r>
-              <a:rPr sz="1250" b="1">
-                <a:solidFill>
-                  <a:srgbClr val="BF2026"/>
-                </a:solidFill>
-                <a:latin typeface="Calibri"/>
-              </a:rPr>
-              <a:t>▪ </a:t>
-            </a:r>
-            <a:r>
-              <a:rPr sz="1250" b="1">
-                <a:solidFill>
-                  <a:srgbClr val="363636"/>
-                </a:solidFill>
-                <a:latin typeface="Calibri"/>
-              </a:rPr>
-              <a:t>Prototipo definido y en implementación: </a:t>
-            </a:r>
-            <a:r>
-              <a:rPr sz="1250" b="0">
-                <a:solidFill>
-                  <a:srgbClr val="363636"/>
-                </a:solidFill>
-                <a:latin typeface="Calibri"/>
-              </a:rPr>
-              <a:t>asistente de sesiones de feedback, elegido entre 4 ideas con demo</a:t>
-            </a:r>
-          </a:p>
-          <a:p>
-            <a:pPr algn="l">
-              <a:lnSpc>
-                <a:spcPct val="105000"/>
-              </a:lnSpc>
-              <a:spcAft>
-                <a:spcPts val="800"/>
-              </a:spcAft>
-            </a:pPr>
-            <a:r>
-              <a:rPr sz="1250" b="1">
-                <a:solidFill>
-                  <a:srgbClr val="BF2026"/>
-                </a:solidFill>
-                <a:latin typeface="Calibri"/>
-              </a:rPr>
-              <a:t>▪ </a:t>
-            </a:r>
-            <a:r>
-              <a:rPr sz="1250" b="1">
-                <a:solidFill>
-                  <a:srgbClr val="363636"/>
-                </a:solidFill>
-                <a:latin typeface="Calibri"/>
-              </a:rPr>
-              <a:t>Ajuste metodológico acordado: </a:t>
-            </a:r>
-            <a:r>
-              <a:rPr sz="1250" b="0">
-                <a:solidFill>
-                  <a:srgbClr val="363636"/>
-                </a:solidFill>
-                <a:latin typeface="Calibri"/>
-              </a:rPr>
-              <a:t>sin entrevistas; la evidencia empírica se concentra en la PoC</a:t>
-            </a:r>
-          </a:p>
-          <a:p>
-            <a:pPr algn="l">
-              <a:lnSpc>
-                <a:spcPct val="105000"/>
-              </a:lnSpc>
-              <a:spcAft>
-                <a:spcPts val="800"/>
-              </a:spcAft>
-            </a:pPr>
-            <a:r>
-              <a:rPr sz="1250" b="1">
-                <a:solidFill>
-                  <a:srgbClr val="BF2026"/>
-                </a:solidFill>
-                <a:latin typeface="Calibri"/>
-              </a:rPr>
-              <a:t>▪ </a:t>
-            </a:r>
-            <a:r>
-              <a:rPr sz="1250" b="1">
-                <a:solidFill>
-                  <a:srgbClr val="363636"/>
-                </a:solidFill>
-                <a:latin typeface="Calibri"/>
-              </a:rPr>
-              <a:t>Revisión presentada como bibliográfica, </a:t>
-            </a:r>
-            <a:r>
-              <a:rPr sz="1250" b="0">
-                <a:solidFill>
-                  <a:srgbClr val="363636"/>
-                </a:solidFill>
-                <a:latin typeface="Calibri"/>
-              </a:rPr>
-              <a:t>no como SLR: el pivot de foco lo hizo más honesto</a:t>
-            </a:r>
-          </a:p>
-          <a:p>
-            <a:pPr algn="l">
-              <a:lnSpc>
-                <a:spcPct val="105000"/>
-              </a:lnSpc>
-              <a:spcAft>
-                <a:spcPts val="800"/>
-              </a:spcAft>
-            </a:pPr>
-            <a:r>
-              <a:rPr sz="1250" b="1">
-                <a:solidFill>
-                  <a:srgbClr val="BF2026"/>
-                </a:solidFill>
-                <a:latin typeface="Calibri"/>
-              </a:rPr>
-              <a:t>▪ </a:t>
-            </a:r>
-            <a:r>
-              <a:rPr sz="1250" b="1">
-                <a:solidFill>
-                  <a:srgbClr val="363636"/>
-                </a:solidFill>
-                <a:latin typeface="Calibri"/>
-              </a:rPr>
-              <a:t>Pendiente en la memoria: </a:t>
-            </a:r>
-            <a:r>
-              <a:rPr sz="1250" b="0">
-                <a:solidFill>
-                  <a:srgbClr val="363636"/>
-                </a:solidFill>
-                <a:latin typeface="Calibri"/>
-              </a:rPr>
-              <a:t>metodología, PoC y conclusiones</a:t>
-            </a:r>
-          </a:p>
-        </p:txBody>
-      </p:sp>
-      <p:sp>
-        <p:nvSpPr>
-          <p:cNvPr id="12" name="Rounded Rectangle 11"/>
-          <p:cNvSpPr/>
-          <p:nvPr/>
-        </p:nvSpPr>
-        <p:spPr>
-          <a:xfrm>
-            <a:off x="6492240" y="5257800"/>
-            <a:ext cx="5212080" cy="1005840"/>
-          </a:xfrm>
-          <a:prstGeom prst="roundRect">
-            <a:avLst/>
-          </a:prstGeom>
-          <a:solidFill>
-            <a:srgbClr val="EDEAE2"/>
-          </a:solidFill>
-          <a:ln>
-            <a:noFill/>
-          </a:ln>
-          <a:effectLst/>
-        </p:spPr>
-        <p:style>
-          <a:lnRef idx="1">
-            <a:schemeClr val="accent1"/>
-          </a:lnRef>
-          <a:fillRef idx="3">
-            <a:schemeClr val="accent1"/>
-          </a:fillRef>
-          <a:effectRef idx="2">
-            <a:schemeClr val="accent1"/>
-          </a:effectRef>
-          <a:fontRef idx="minor">
-            <a:schemeClr val="lt1"/>
-          </a:fontRef>
-        </p:style>
-        <p:txBody>
-          <a:bodyPr rtlCol="0" anchor="ctr"/>
-          <a:lstStyle/>
-          <a:p>
-            <a:pPr algn="ctr"/>
-          </a:p>
-        </p:txBody>
-      </p:sp>
-      <p:sp>
-        <p:nvSpPr>
-          <p:cNvPr id="13" name="TextBox 12"/>
-          <p:cNvSpPr txBox="1"/>
-          <p:nvPr/>
-        </p:nvSpPr>
-        <p:spPr>
-          <a:xfrm>
-            <a:off x="6720840" y="5349240"/>
-            <a:ext cx="4754880" cy="868680"/>
-          </a:xfrm>
-          <a:prstGeom prst="rect">
-            <a:avLst/>
-          </a:prstGeom>
-          <a:noFill/>
-        </p:spPr>
-        <p:txBody>
-          <a:bodyPr wrap="square" anchor="ctr" lIns="25400" rIns="25400" tIns="12700" bIns="12700">
-            <a:spAutoFit/>
-          </a:bodyPr>
-          <a:lstStyle/>
-          <a:p>
-            <a:pPr algn="l">
-              <a:lnSpc>
-                <a:spcPct val="110000"/>
-              </a:lnSpc>
-              <a:spcAft>
-                <a:spcPts val="400"/>
-              </a:spcAft>
-            </a:pPr>
-            <a:r>
-              <a:rPr sz="1200" b="1">
-                <a:solidFill>
-                  <a:srgbClr val="661020"/>
-                </a:solidFill>
-                <a:latin typeface="Calibri"/>
-              </a:rPr>
-              <a:t>Decisiones de 20 calls con el tutor auditadas y documentadas sprint a sprint</a:t>
+              <a:t>La PoC explora ese espacio.</a:t>
             </a:r>
           </a:p>
         </p:txBody>
@@ -7000,8 +6834,8 @@
         </p:nvSpPr>
         <p:spPr>
           <a:xfrm>
-            <a:off x="8229600" y="411480"/>
-            <a:ext cx="3429000" cy="457200"/>
+            <a:off x="502920" y="1234440"/>
+            <a:ext cx="3977639" cy="1463040"/>
           </a:xfrm>
           <a:prstGeom prst="rect">
             <a:avLst/>
@@ -7014,22 +6848,22 @@
           </a:bodyPr>
           <a:lstStyle/>
           <a:p>
-            <a:pPr algn="r">
-              <a:lnSpc>
-                <a:spcPct val="100000"/>
+            <a:pPr algn="l">
+              <a:lnSpc>
+                <a:spcPct val="115000"/>
               </a:lnSpc>
               <a:spcAft>
                 <a:spcPts val="400"/>
               </a:spcAft>
             </a:pPr>
             <a:r>
-              <a:rPr sz="1100" b="0">
-                <a:solidFill>
-                  <a:srgbClr val="6B6B6B"/>
-                </a:solidFill>
-                <a:latin typeface="Calibri"/>
-              </a:rPr>
-              <a:t>Objetivo F · en implementación</a:t>
+              <a:rPr sz="1300" b="0">
+                <a:solidFill>
+                  <a:srgbClr val="363636"/>
+                </a:solidFill>
+                <a:latin typeface="Calibri"/>
+              </a:rPr>
+              <a:t>Escucha al cliente en la reunión, confronta cada enunciado contra la documentación del proyecto y responde al momento, con la cita exacta.</a:t>
             </a:r>
           </a:p>
         </p:txBody>
@@ -7042,8 +6876,8 @@
         </p:nvSpPr>
         <p:spPr>
           <a:xfrm>
-            <a:off x="502920" y="1188720"/>
-            <a:ext cx="5120640" cy="1600200"/>
+            <a:off x="502920" y="2606040"/>
+            <a:ext cx="3977639" cy="411480"/>
           </a:xfrm>
           <a:prstGeom prst="rect">
             <a:avLst/>
@@ -7058,126 +6892,19 @@
           <a:p>
             <a:pPr algn="l">
               <a:lnSpc>
-                <a:spcPct val="105000"/>
-              </a:lnSpc>
-              <a:spcAft>
-                <a:spcPts val="600"/>
-              </a:spcAft>
-            </a:pPr>
-            <a:r>
-              <a:rPr sz="1250" b="1">
+                <a:spcPct val="100000"/>
+              </a:lnSpc>
+              <a:spcAft>
+                <a:spcPts val="400"/>
+              </a:spcAft>
+            </a:pPr>
+            <a:r>
+              <a:rPr sz="1350" b="1">
                 <a:solidFill>
                   <a:srgbClr val="BF2026"/>
                 </a:solidFill>
                 <a:latin typeface="Calibri"/>
               </a:rPr>
-              <a:t>▪ </a:t>
-            </a:r>
-            <a:r>
-              <a:rPr sz="1250" b="0">
-                <a:solidFill>
-                  <a:srgbClr val="363636"/>
-                </a:solidFill>
-                <a:latin typeface="Calibri"/>
-              </a:rPr>
-              <a:t>Escucha al cliente en la propia reunión de feedback</a:t>
-            </a:r>
-          </a:p>
-          <a:p>
-            <a:pPr algn="l">
-              <a:lnSpc>
-                <a:spcPct val="105000"/>
-              </a:lnSpc>
-              <a:spcAft>
-                <a:spcPts val="600"/>
-              </a:spcAft>
-            </a:pPr>
-            <a:r>
-              <a:rPr sz="1250" b="1">
-                <a:solidFill>
-                  <a:srgbClr val="BF2026"/>
-                </a:solidFill>
-                <a:latin typeface="Calibri"/>
-              </a:rPr>
-              <a:t>▪ </a:t>
-            </a:r>
-            <a:r>
-              <a:rPr sz="1250" b="0">
-                <a:solidFill>
-                  <a:srgbClr val="363636"/>
-                </a:solidFill>
-                <a:latin typeface="Calibri"/>
-              </a:rPr>
-              <a:t>Confronta cada enunciado contra la documentación del proyecto</a:t>
-            </a:r>
-          </a:p>
-          <a:p>
-            <a:pPr algn="l">
-              <a:lnSpc>
-                <a:spcPct val="105000"/>
-              </a:lnSpc>
-              <a:spcAft>
-                <a:spcPts val="600"/>
-              </a:spcAft>
-            </a:pPr>
-            <a:r>
-              <a:rPr sz="1250" b="1">
-                <a:solidFill>
-                  <a:srgbClr val="BF2026"/>
-                </a:solidFill>
-                <a:latin typeface="Calibri"/>
-              </a:rPr>
-              <a:t>▪ </a:t>
-            </a:r>
-            <a:r>
-              <a:rPr sz="1250" b="0">
-                <a:solidFill>
-                  <a:srgbClr val="363636"/>
-                </a:solidFill>
-                <a:latin typeface="Calibri"/>
-              </a:rPr>
-              <a:t>Responde al momento, con la cita exacta del documento</a:t>
-            </a:r>
-          </a:p>
-        </p:txBody>
-      </p:sp>
-      <p:sp>
-        <p:nvSpPr>
-          <p:cNvPr id="6" name="TextBox 5"/>
-          <p:cNvSpPr txBox="1"/>
-          <p:nvPr/>
-        </p:nvSpPr>
-        <p:spPr>
-          <a:xfrm>
-            <a:off x="502920" y="2743200"/>
-            <a:ext cx="5120640" cy="411480"/>
-          </a:xfrm>
-          <a:prstGeom prst="rect">
-            <a:avLst/>
-          </a:prstGeom>
-          <a:noFill/>
-        </p:spPr>
-        <p:txBody>
-          <a:bodyPr wrap="square" anchor="t" lIns="25400" rIns="25400" tIns="12700" bIns="12700">
-            <a:spAutoFit/>
-          </a:bodyPr>
-          <a:lstStyle/>
-          <a:p>
-            <a:pPr algn="l">
-              <a:lnSpc>
-                <a:spcPct val="100000"/>
-              </a:lnSpc>
-              <a:spcAft>
-                <a:spcPts val="400"/>
-              </a:spcAft>
-            </a:pPr>
-            <a:r>
-              <a:rPr sz="1350" b="1">
-                <a:solidFill>
-                  <a:srgbClr val="BF2026"/>
-                </a:solidFill>
-                <a:latin typeface="Calibri"/>
-              </a:rPr>
               <a:t>La devolución pasa de días a segundos.</a:t>
             </a:r>
           </a:p>
@@ -7185,14 +6912,14 @@
       </p:sp>
       <p:sp>
         <p:nvSpPr>
-          <p:cNvPr id="7" name="Rectangle 6"/>
+          <p:cNvPr id="6" name="Rectangle 5"/>
           <p:cNvSpPr/>
           <p:nvPr/>
         </p:nvSpPr>
         <p:spPr>
           <a:xfrm>
-            <a:off x="502920" y="3291840"/>
-            <a:ext cx="82296" cy="566928"/>
+            <a:off x="502920" y="3246120"/>
+            <a:ext cx="82296" cy="603504"/>
           </a:xfrm>
           <a:prstGeom prst="rect">
             <a:avLst/>
@@ -7229,14 +6956,14 @@
       </p:sp>
       <p:sp>
         <p:nvSpPr>
-          <p:cNvPr id="8" name="Rounded Rectangle 7"/>
+          <p:cNvPr id="7" name="Rounded Rectangle 6"/>
           <p:cNvSpPr/>
           <p:nvPr/>
         </p:nvSpPr>
         <p:spPr>
           <a:xfrm>
-            <a:off x="585216" y="3291840"/>
-            <a:ext cx="5029200" cy="566928"/>
+            <a:off x="585216" y="3246120"/>
+            <a:ext cx="3895344" cy="603504"/>
           </a:xfrm>
           <a:prstGeom prst="roundRect">
             <a:avLst/>
@@ -7273,14 +7000,14 @@
       </p:sp>
       <p:sp>
         <p:nvSpPr>
-          <p:cNvPr id="9" name="TextBox 8"/>
+          <p:cNvPr id="8" name="TextBox 7"/>
           <p:cNvSpPr txBox="1"/>
           <p:nvPr/>
         </p:nvSpPr>
         <p:spPr>
           <a:xfrm>
-            <a:off x="777240" y="3291840"/>
-            <a:ext cx="4754880" cy="566928"/>
+            <a:off x="777240" y="3246120"/>
+            <a:ext cx="3611880" cy="603504"/>
           </a:xfrm>
           <a:prstGeom prst="rect">
             <a:avLst/>
@@ -7298,7 +7025,7 @@
                 <a:spcPct val="100000"/>
               </a:lnSpc>
               <a:spcAft>
-                <a:spcPts val="400"/>
+                <a:spcPts val="100"/>
               </a:spcAft>
             </a:pPr>
             <a:r>
@@ -7308,10 +7035,20 @@
                 </a:solidFill>
                 <a:latin typeface="Calibri"/>
               </a:rPr>
-              <a:t>Choca con lo acordado · </a:t>
-            </a:r>
-            <a:r>
-              <a:rPr sz="1150" b="0">
+              <a:t>Choca con lo acordado</a:t>
+            </a:r>
+          </a:p>
+          <a:p>
+            <a:pPr algn="l">
+              <a:lnSpc>
+                <a:spcPct val="100000"/>
+              </a:lnSpc>
+              <a:spcAft>
+                <a:spcPts val="100"/>
+              </a:spcAft>
+            </a:pPr>
+            <a:r>
+              <a:rPr sz="1050" b="0">
                 <a:solidFill>
                   <a:srgbClr val="363636"/>
                 </a:solidFill>
@@ -7324,14 +7061,14 @@
       </p:sp>
       <p:sp>
         <p:nvSpPr>
-          <p:cNvPr id="10" name="Rectangle 9"/>
+          <p:cNvPr id="9" name="Rectangle 8"/>
           <p:cNvSpPr/>
           <p:nvPr/>
         </p:nvSpPr>
         <p:spPr>
           <a:xfrm>
-            <a:off x="502920" y="4005072"/>
-            <a:ext cx="82296" cy="566928"/>
+            <a:off x="502920" y="3995928"/>
+            <a:ext cx="82296" cy="603504"/>
           </a:xfrm>
           <a:prstGeom prst="rect">
             <a:avLst/>
@@ -7368,14 +7105,14 @@
       </p:sp>
       <p:sp>
         <p:nvSpPr>
-          <p:cNvPr id="11" name="Rounded Rectangle 10"/>
+          <p:cNvPr id="10" name="Rounded Rectangle 9"/>
           <p:cNvSpPr/>
           <p:nvPr/>
         </p:nvSpPr>
         <p:spPr>
           <a:xfrm>
-            <a:off x="585216" y="4005072"/>
-            <a:ext cx="5029200" cy="566928"/>
+            <a:off x="585216" y="3995928"/>
+            <a:ext cx="3895344" cy="603504"/>
           </a:xfrm>
           <a:prstGeom prst="roundRect">
             <a:avLst/>
@@ -7412,14 +7149,14 @@
       </p:sp>
       <p:sp>
         <p:nvSpPr>
-          <p:cNvPr id="12" name="TextBox 11"/>
+          <p:cNvPr id="11" name="TextBox 10"/>
           <p:cNvSpPr txBox="1"/>
           <p:nvPr/>
         </p:nvSpPr>
         <p:spPr>
           <a:xfrm>
-            <a:off x="777240" y="4005072"/>
-            <a:ext cx="4754880" cy="566928"/>
+            <a:off x="777240" y="3995928"/>
+            <a:ext cx="3611880" cy="603504"/>
           </a:xfrm>
           <a:prstGeom prst="rect">
             <a:avLst/>
@@ -7437,7 +7174,7 @@
                 <a:spcPct val="100000"/>
               </a:lnSpc>
               <a:spcAft>
-                <a:spcPts val="400"/>
+                <a:spcPts val="100"/>
               </a:spcAft>
             </a:pPr>
             <a:r>
@@ -7447,10 +7184,20 @@
                 </a:solidFill>
                 <a:latin typeface="Calibri"/>
               </a:rPr>
-              <a:t>Coincide con lo acordado · </a:t>
-            </a:r>
-            <a:r>
-              <a:rPr sz="1150" b="0">
+              <a:t>Coincide con lo acordado</a:t>
+            </a:r>
+          </a:p>
+          <a:p>
+            <a:pPr algn="l">
+              <a:lnSpc>
+                <a:spcPct val="100000"/>
+              </a:lnSpc>
+              <a:spcAft>
+                <a:spcPts val="100"/>
+              </a:spcAft>
+            </a:pPr>
+            <a:r>
+              <a:rPr sz="1050" b="0">
                 <a:solidFill>
                   <a:srgbClr val="363636"/>
                 </a:solidFill>
@@ -7463,14 +7210,14 @@
       </p:sp>
       <p:sp>
         <p:nvSpPr>
-          <p:cNvPr id="13" name="Rectangle 12"/>
+          <p:cNvPr id="12" name="Rectangle 11"/>
           <p:cNvSpPr/>
           <p:nvPr/>
         </p:nvSpPr>
         <p:spPr>
           <a:xfrm>
-            <a:off x="502920" y="4718304"/>
-            <a:ext cx="82296" cy="566928"/>
+            <a:off x="502920" y="4745736"/>
+            <a:ext cx="82296" cy="603504"/>
           </a:xfrm>
           <a:prstGeom prst="rect">
             <a:avLst/>
@@ -7507,14 +7254,14 @@
       </p:sp>
       <p:sp>
         <p:nvSpPr>
-          <p:cNvPr id="14" name="Rounded Rectangle 13"/>
+          <p:cNvPr id="13" name="Rounded Rectangle 12"/>
           <p:cNvSpPr/>
           <p:nvPr/>
         </p:nvSpPr>
         <p:spPr>
           <a:xfrm>
-            <a:off x="585216" y="4718304"/>
-            <a:ext cx="5029200" cy="566928"/>
+            <a:off x="585216" y="4745736"/>
+            <a:ext cx="3895344" cy="603504"/>
           </a:xfrm>
           <a:prstGeom prst="roundRect">
             <a:avLst/>
@@ -7551,14 +7298,14 @@
       </p:sp>
       <p:sp>
         <p:nvSpPr>
-          <p:cNvPr id="15" name="TextBox 14"/>
+          <p:cNvPr id="14" name="TextBox 13"/>
           <p:cNvSpPr txBox="1"/>
           <p:nvPr/>
         </p:nvSpPr>
         <p:spPr>
           <a:xfrm>
-            <a:off x="777240" y="4718304"/>
-            <a:ext cx="4754880" cy="566928"/>
+            <a:off x="777240" y="4745736"/>
+            <a:ext cx="3611880" cy="603504"/>
           </a:xfrm>
           <a:prstGeom prst="rect">
             <a:avLst/>
@@ -7576,7 +7323,7 @@
                 <a:spcPct val="100000"/>
               </a:lnSpc>
               <a:spcAft>
-                <a:spcPts val="400"/>
+                <a:spcPts val="100"/>
               </a:spcAft>
             </a:pPr>
             <a:r>
@@ -7586,23 +7333,33 @@
                 </a:solidFill>
                 <a:latin typeface="Calibri"/>
               </a:rPr>
-              <a:t>No está contemplado · </a:t>
-            </a:r>
-            <a:r>
-              <a:rPr sz="1150" b="0">
+              <a:t>No está contemplado</a:t>
+            </a:r>
+          </a:p>
+          <a:p>
+            <a:pPr algn="l">
+              <a:lnSpc>
+                <a:spcPct val="100000"/>
+              </a:lnSpc>
+              <a:spcAft>
+                <a:spcPts val="100"/>
+              </a:spcAft>
+            </a:pPr>
+            <a:r>
+              <a:rPr sz="1050" b="0">
                 <a:solidFill>
                   <a:srgbClr val="363636"/>
                 </a:solidFill>
                 <a:latin typeface="Calibri"/>
               </a:rPr>
-              <a:t>pedido nuevo: se prioriza, puede salir como ticket</a:t>
+              <a:t>pedido nuevo, se prioriza</a:t>
             </a:r>
           </a:p>
         </p:txBody>
       </p:sp>
       <p:pic>
         <p:nvPicPr>
-          <p:cNvPr id="16" name="Picture 15" descr="frame_44.png"/>
+          <p:cNvPr id="15" name="Picture 14" descr="frame_44.png"/>
           <p:cNvPicPr>
             <a:picLocks noChangeAspect="1"/>
           </p:cNvPicPr>
@@ -7616,8 +7373,8 @@
         </p:blipFill>
         <p:spPr>
           <a:xfrm>
-            <a:off x="5897880" y="1234440"/>
-            <a:ext cx="5852160" cy="3291840"/>
+            <a:off x="4754880" y="1234440"/>
+            <a:ext cx="7178040" cy="4037648"/>
           </a:xfrm>
           <a:prstGeom prst="rect">
             <a:avLst/>
@@ -7631,14 +7388,14 @@
       </p:pic>
       <p:sp>
         <p:nvSpPr>
-          <p:cNvPr id="17" name="TextBox 16"/>
+          <p:cNvPr id="16" name="TextBox 15"/>
           <p:cNvSpPr txBox="1"/>
           <p:nvPr/>
         </p:nvSpPr>
         <p:spPr>
           <a:xfrm>
-            <a:off x="5897880" y="4572000"/>
-            <a:ext cx="5852160" cy="365760"/>
+            <a:off x="4754880" y="5349240"/>
+            <a:ext cx="7178040" cy="365760"/>
           </a:xfrm>
           <a:prstGeom prst="rect">
             <a:avLst/>
@@ -7666,21 +7423,21 @@
                 </a:solidFill>
                 <a:latin typeface="Calibri"/>
               </a:rPr>
-              <a:t>Demo del prototipo · dominio de prueba: biblioteca universitaria</a:t>
-            </a:r>
-          </a:p>
-        </p:txBody>
-      </p:sp>
-      <p:sp>
-        <p:nvSpPr>
-          <p:cNvPr id="18" name="Rounded Rectangle 17"/>
+              <a:t>Demo · dominio de prueba: una biblioteca universitaria y su sistema de préstamos</a:t>
+            </a:r>
+          </a:p>
+        </p:txBody>
+      </p:sp>
+      <p:sp>
+        <p:nvSpPr>
+          <p:cNvPr id="17" name="Rounded Rectangle 16"/>
           <p:cNvSpPr/>
           <p:nvPr/>
         </p:nvSpPr>
         <p:spPr>
           <a:xfrm>
-            <a:off x="502920" y="5760720"/>
-            <a:ext cx="11201400" cy="685800"/>
+            <a:off x="502920" y="5897880"/>
+            <a:ext cx="11201400" cy="594360"/>
           </a:xfrm>
           <a:prstGeom prst="roundRect">
             <a:avLst/>
@@ -7717,14 +7474,14 @@
       </p:sp>
       <p:sp>
         <p:nvSpPr>
-          <p:cNvPr id="19" name="TextBox 18"/>
+          <p:cNvPr id="18" name="TextBox 17"/>
           <p:cNvSpPr txBox="1"/>
           <p:nvPr/>
         </p:nvSpPr>
         <p:spPr>
           <a:xfrm>
-            <a:off x="777240" y="5806440"/>
-            <a:ext cx="10698480" cy="594360"/>
+            <a:off x="777240" y="5925312"/>
+            <a:ext cx="10698480" cy="548640"/>
           </a:xfrm>
           <a:prstGeom prst="rect">
             <a:avLst/>
@@ -7752,7 +7509,7 @@
                 </a:solidFill>
                 <a:latin typeface="Calibri"/>
               </a:rPr>
-              <a:t>Estado: demo visual lista · documentación de prueba con una contradicción y un hueco plantados · aplicación web en desarrollo</a:t>
+              <a:t>Estado: v1 funcionando con entrada escrita y veredictos con cita verificada</a:t>
             </a:r>
           </a:p>
         </p:txBody>
@@ -7863,56 +7620,14 @@
       </p:sp>
       <p:sp>
         <p:nvSpPr>
-          <p:cNvPr id="4" name="TextBox 3"/>
-          <p:cNvSpPr txBox="1"/>
-          <p:nvPr/>
-        </p:nvSpPr>
-        <p:spPr>
-          <a:xfrm>
-            <a:off x="8229600" y="411480"/>
-            <a:ext cx="3429000" cy="457200"/>
-          </a:xfrm>
-          <a:prstGeom prst="rect">
-            <a:avLst/>
-          </a:prstGeom>
-          <a:noFill/>
-        </p:spPr>
-        <p:txBody>
-          <a:bodyPr wrap="square" anchor="t" lIns="25400" rIns="25400" tIns="12700" bIns="12700">
-            <a:spAutoFit/>
-          </a:bodyPr>
-          <a:lstStyle/>
-          <a:p>
-            <a:pPr algn="r">
-              <a:lnSpc>
-                <a:spcPct val="100000"/>
-              </a:lnSpc>
-              <a:spcAft>
-                <a:spcPts val="400"/>
-              </a:spcAft>
-            </a:pPr>
-            <a:r>
-              <a:rPr sz="1100" b="0">
-                <a:solidFill>
-                  <a:srgbClr val="6B6B6B"/>
-                </a:solidFill>
-                <a:latin typeface="Calibri"/>
-              </a:rPr>
-              <a:t>Octubre 2026 · marzo 2027</a:t>
-            </a:r>
-          </a:p>
-        </p:txBody>
-      </p:sp>
-      <p:sp>
-        <p:nvSpPr>
-          <p:cNvPr id="5" name="Rounded Rectangle 4"/>
+          <p:cNvPr id="4" name="Rounded Rectangle 3"/>
           <p:cNvSpPr/>
           <p:nvPr/>
         </p:nvSpPr>
         <p:spPr>
           <a:xfrm>
-            <a:off x="640080" y="1325880"/>
-            <a:ext cx="1737360" cy="841248"/>
+            <a:off x="640080" y="1463040"/>
+            <a:ext cx="1737360" cy="987552"/>
           </a:xfrm>
           <a:prstGeom prst="roundRect">
             <a:avLst/>
@@ -7949,14 +7664,14 @@
       </p:sp>
       <p:sp>
         <p:nvSpPr>
-          <p:cNvPr id="6" name="TextBox 5"/>
+          <p:cNvPr id="5" name="TextBox 4"/>
           <p:cNvSpPr txBox="1"/>
           <p:nvPr/>
         </p:nvSpPr>
         <p:spPr>
           <a:xfrm>
-            <a:off x="640080" y="1325880"/>
-            <a:ext cx="1737360" cy="841248"/>
+            <a:off x="640080" y="1463040"/>
+            <a:ext cx="1737360" cy="987552"/>
           </a:xfrm>
           <a:prstGeom prst="rect">
             <a:avLst/>
@@ -7984,21 +7699,21 @@
                 </a:solidFill>
                 <a:latin typeface="Calibri"/>
               </a:rPr>
-              <a:t>OCT</a:t>
-            </a:r>
-          </a:p>
-        </p:txBody>
-      </p:sp>
-      <p:sp>
-        <p:nvSpPr>
-          <p:cNvPr id="7" name="TextBox 6"/>
+              <a:t>OCT · NOV</a:t>
+            </a:r>
+          </a:p>
+        </p:txBody>
+      </p:sp>
+      <p:sp>
+        <p:nvSpPr>
+          <p:cNvPr id="6" name="TextBox 5"/>
           <p:cNvSpPr txBox="1"/>
           <p:nvPr/>
         </p:nvSpPr>
         <p:spPr>
           <a:xfrm>
-            <a:off x="2697480" y="1389888"/>
-            <a:ext cx="2834640" cy="841248"/>
+            <a:off x="2697480" y="1527048"/>
+            <a:ext cx="2834640" cy="987552"/>
           </a:xfrm>
           <a:prstGeom prst="rect">
             <a:avLst/>
@@ -8026,21 +7741,21 @@
                 </a:solidFill>
                 <a:latin typeface="Calibri"/>
               </a:rPr>
-              <a:t>PoC paso 1</a:t>
-            </a:r>
-          </a:p>
-        </p:txBody>
-      </p:sp>
-      <p:sp>
-        <p:nvSpPr>
-          <p:cNvPr id="8" name="TextBox 7"/>
+              <a:t>Desarrollo de la PoC</a:t>
+            </a:r>
+          </a:p>
+        </p:txBody>
+      </p:sp>
+      <p:sp>
+        <p:nvSpPr>
+          <p:cNvPr id="7" name="TextBox 6"/>
           <p:cNvSpPr txBox="1"/>
           <p:nvPr/>
         </p:nvSpPr>
         <p:spPr>
           <a:xfrm>
-            <a:off x="5577840" y="1389888"/>
-            <a:ext cx="6126480" cy="841248"/>
+            <a:off x="5577840" y="1527048"/>
+            <a:ext cx="6126480" cy="987552"/>
           </a:xfrm>
           <a:prstGeom prst="rect">
             <a:avLst/>
@@ -8068,21 +7783,21 @@
                 </a:solidFill>
                 <a:latin typeface="Calibri"/>
               </a:rPr>
-              <a:t>Entrada escrita confrontada contra la documentación</a:t>
-            </a:r>
-          </a:p>
-        </p:txBody>
-      </p:sp>
-      <p:sp>
-        <p:nvSpPr>
-          <p:cNvPr id="9" name="Rounded Rectangle 8"/>
+              <a:t>Completar el asistente: micrófono y transcripción en vivo (la entrada escrita ya funciona)</a:t>
+            </a:r>
+          </a:p>
+        </p:txBody>
+      </p:sp>
+      <p:sp>
+        <p:nvSpPr>
+          <p:cNvPr id="8" name="Rounded Rectangle 7"/>
           <p:cNvSpPr/>
           <p:nvPr/>
         </p:nvSpPr>
         <p:spPr>
           <a:xfrm>
-            <a:off x="640080" y="2276856"/>
-            <a:ext cx="1737360" cy="841248"/>
+            <a:off x="640080" y="2560320"/>
+            <a:ext cx="1737360" cy="987552"/>
           </a:xfrm>
           <a:prstGeom prst="roundRect">
             <a:avLst/>
@@ -8119,14 +7834,14 @@
       </p:sp>
       <p:sp>
         <p:nvSpPr>
-          <p:cNvPr id="10" name="TextBox 9"/>
+          <p:cNvPr id="9" name="TextBox 8"/>
           <p:cNvSpPr txBox="1"/>
           <p:nvPr/>
         </p:nvSpPr>
         <p:spPr>
           <a:xfrm>
-            <a:off x="640080" y="2276856"/>
-            <a:ext cx="1737360" cy="841248"/>
+            <a:off x="640080" y="2560320"/>
+            <a:ext cx="1737360" cy="987552"/>
           </a:xfrm>
           <a:prstGeom prst="rect">
             <a:avLst/>
@@ -8154,21 +7869,21 @@
                 </a:solidFill>
                 <a:latin typeface="Calibri"/>
               </a:rPr>
-              <a:t>OCT · NOV</a:t>
-            </a:r>
-          </a:p>
-        </p:txBody>
-      </p:sp>
-      <p:sp>
-        <p:nvSpPr>
-          <p:cNvPr id="11" name="TextBox 10"/>
+              <a:t>NOV · DIC</a:t>
+            </a:r>
+          </a:p>
+        </p:txBody>
+      </p:sp>
+      <p:sp>
+        <p:nvSpPr>
+          <p:cNvPr id="10" name="TextBox 9"/>
           <p:cNvSpPr txBox="1"/>
           <p:nvPr/>
         </p:nvSpPr>
         <p:spPr>
           <a:xfrm>
-            <a:off x="2697480" y="2340864"/>
-            <a:ext cx="2834640" cy="841248"/>
+            <a:off x="2697480" y="2624328"/>
+            <a:ext cx="2834640" cy="987552"/>
           </a:xfrm>
           <a:prstGeom prst="rect">
             <a:avLst/>
@@ -8196,21 +7911,21 @@
                 </a:solidFill>
                 <a:latin typeface="Calibri"/>
               </a:rPr>
-              <a:t>PoC paso 2</a:t>
-            </a:r>
-          </a:p>
-        </p:txBody>
-      </p:sp>
-      <p:sp>
-        <p:nvSpPr>
-          <p:cNvPr id="12" name="TextBox 11"/>
+              <a:t>Validación de la PoC</a:t>
+            </a:r>
+          </a:p>
+        </p:txBody>
+      </p:sp>
+      <p:sp>
+        <p:nvSpPr>
+          <p:cNvPr id="11" name="TextBox 10"/>
           <p:cNvSpPr txBox="1"/>
           <p:nvPr/>
         </p:nvSpPr>
         <p:spPr>
           <a:xfrm>
-            <a:off x="5577840" y="2340864"/>
-            <a:ext cx="6126480" cy="841248"/>
+            <a:off x="5577840" y="2624328"/>
+            <a:ext cx="6126480" cy="987552"/>
           </a:xfrm>
           <a:prstGeom prst="rect">
             <a:avLst/>
@@ -8238,21 +7953,21 @@
                 </a:solidFill>
                 <a:latin typeface="Calibri"/>
               </a:rPr>
-              <a:t>Micrófono y transcripción en vivo; documentación anonimizada de un proyecto real</a:t>
-            </a:r>
-          </a:p>
-        </p:txBody>
-      </p:sp>
-      <p:sp>
-        <p:nvSpPr>
-          <p:cNvPr id="13" name="Rounded Rectangle 12"/>
+              <a:t>El tipo de validación está a definir con el tutor</a:t>
+            </a:r>
+          </a:p>
+        </p:txBody>
+      </p:sp>
+      <p:sp>
+        <p:nvSpPr>
+          <p:cNvPr id="12" name="Rounded Rectangle 11"/>
           <p:cNvSpPr/>
           <p:nvPr/>
         </p:nvSpPr>
         <p:spPr>
           <a:xfrm>
-            <a:off x="640080" y="3227832"/>
-            <a:ext cx="1737360" cy="841248"/>
+            <a:off x="640080" y="3657600"/>
+            <a:ext cx="1737360" cy="987552"/>
           </a:xfrm>
           <a:prstGeom prst="roundRect">
             <a:avLst/>
@@ -8289,14 +8004,14 @@
       </p:sp>
       <p:sp>
         <p:nvSpPr>
-          <p:cNvPr id="14" name="TextBox 13"/>
+          <p:cNvPr id="13" name="TextBox 12"/>
           <p:cNvSpPr txBox="1"/>
           <p:nvPr/>
         </p:nvSpPr>
         <p:spPr>
           <a:xfrm>
-            <a:off x="640080" y="3227832"/>
-            <a:ext cx="1737360" cy="841248"/>
+            <a:off x="640080" y="3657600"/>
+            <a:ext cx="1737360" cy="987552"/>
           </a:xfrm>
           <a:prstGeom prst="rect">
             <a:avLst/>
@@ -8324,21 +8039,21 @@
                 </a:solidFill>
                 <a:latin typeface="Calibri"/>
               </a:rPr>
-              <a:t>NOV · DIC</a:t>
-            </a:r>
-          </a:p>
-        </p:txBody>
-      </p:sp>
-      <p:sp>
-        <p:nvSpPr>
-          <p:cNvPr id="15" name="TextBox 14"/>
+              <a:t>DIC · FEB</a:t>
+            </a:r>
+          </a:p>
+        </p:txBody>
+      </p:sp>
+      <p:sp>
+        <p:nvSpPr>
+          <p:cNvPr id="14" name="TextBox 13"/>
           <p:cNvSpPr txBox="1"/>
           <p:nvPr/>
         </p:nvSpPr>
         <p:spPr>
           <a:xfrm>
-            <a:off x="2697480" y="3291840"/>
-            <a:ext cx="2834640" cy="841248"/>
+            <a:off x="2697480" y="3721608"/>
+            <a:ext cx="2834640" cy="987552"/>
           </a:xfrm>
           <a:prstGeom prst="rect">
             <a:avLst/>
@@ -8366,21 +8081,21 @@
                 </a:solidFill>
                 <a:latin typeface="Calibri"/>
               </a:rPr>
-              <a:t>Validación</a:t>
-            </a:r>
-          </a:p>
-        </p:txBody>
-      </p:sp>
-      <p:sp>
-        <p:nvSpPr>
-          <p:cNvPr id="16" name="TextBox 15"/>
+              <a:t>Cierre del documento</a:t>
+            </a:r>
+          </a:p>
+        </p:txBody>
+      </p:sp>
+      <p:sp>
+        <p:nvSpPr>
+          <p:cNvPr id="15" name="TextBox 14"/>
           <p:cNvSpPr txBox="1"/>
           <p:nvPr/>
         </p:nvSpPr>
         <p:spPr>
           <a:xfrm>
-            <a:off x="5577840" y="3291840"/>
-            <a:ext cx="6126480" cy="841248"/>
+            <a:off x="5577840" y="3721608"/>
+            <a:ext cx="6126480" cy="987552"/>
           </a:xfrm>
           <a:prstGeom prst="rect">
             <a:avLst/>
@@ -8408,23 +8123,211 @@
                 </a:solidFill>
                 <a:latin typeface="Calibri"/>
               </a:rPr>
-              <a:t>Sesiones con 5 a 20 actores de negocio; registro estructurado de cada sesión</a:t>
-            </a:r>
-          </a:p>
-        </p:txBody>
-      </p:sp>
-      <p:sp>
-        <p:nvSpPr>
-          <p:cNvPr id="17" name="Rounded Rectangle 16"/>
+              <a:t>Resultados de la validación, capítulo de la PoC, metodología y conclusiones</a:t>
+            </a:r>
+          </a:p>
+        </p:txBody>
+      </p:sp>
+      <p:sp>
+        <p:nvSpPr>
+          <p:cNvPr id="16" name="Rounded Rectangle 15"/>
           <p:cNvSpPr/>
           <p:nvPr/>
         </p:nvSpPr>
         <p:spPr>
           <a:xfrm>
-            <a:off x="640080" y="4178808"/>
-            <a:ext cx="1737360" cy="841248"/>
+            <a:off x="640080" y="4754880"/>
+            <a:ext cx="1737360" cy="987552"/>
           </a:xfrm>
           <a:prstGeom prst="roundRect">
+            <a:avLst/>
+          </a:prstGeom>
+          <a:solidFill>
+            <a:srgbClr val="BF2026"/>
+          </a:solidFill>
+          <a:ln>
+            <a:noFill/>
+          </a:ln>
+          <a:effectLst/>
+        </p:spPr>
+        <p:style>
+          <a:lnRef idx="1">
+            <a:schemeClr val="accent1"/>
+          </a:lnRef>
+          <a:fillRef idx="3">
+            <a:schemeClr val="accent1"/>
+          </a:fillRef>
+          <a:effectRef idx="2">
+            <a:schemeClr val="accent1"/>
+          </a:effectRef>
+          <a:fontRef idx="minor">
+            <a:schemeClr val="lt1"/>
+          </a:fontRef>
+        </p:style>
+        <p:txBody>
+          <a:bodyPr rtlCol="0" anchor="ctr"/>
+          <a:lstStyle/>
+          <a:p>
+            <a:pPr algn="ctr"/>
+          </a:p>
+        </p:txBody>
+      </p:sp>
+      <p:sp>
+        <p:nvSpPr>
+          <p:cNvPr id="17" name="TextBox 16"/>
+          <p:cNvSpPr txBox="1"/>
+          <p:nvPr/>
+        </p:nvSpPr>
+        <p:spPr>
+          <a:xfrm>
+            <a:off x="640080" y="4754880"/>
+            <a:ext cx="1737360" cy="987552"/>
+          </a:xfrm>
+          <a:prstGeom prst="rect">
+            <a:avLst/>
+          </a:prstGeom>
+          <a:noFill/>
+        </p:spPr>
+        <p:txBody>
+          <a:bodyPr wrap="square" anchor="ctr" lIns="25400" rIns="25400" tIns="12700" bIns="12700">
+            <a:spAutoFit/>
+          </a:bodyPr>
+          <a:lstStyle/>
+          <a:p>
+            <a:pPr algn="ctr">
+              <a:lnSpc>
+                <a:spcPct val="100000"/>
+              </a:lnSpc>
+              <a:spcAft>
+                <a:spcPts val="400"/>
+              </a:spcAft>
+            </a:pPr>
+            <a:r>
+              <a:rPr sz="1250" b="1">
+                <a:solidFill>
+                  <a:srgbClr val="FFFFFF"/>
+                </a:solidFill>
+                <a:latin typeface="Calibri"/>
+              </a:rPr>
+              <a:t>MAR 2027</a:t>
+            </a:r>
+          </a:p>
+        </p:txBody>
+      </p:sp>
+      <p:sp>
+        <p:nvSpPr>
+          <p:cNvPr id="18" name="TextBox 17"/>
+          <p:cNvSpPr txBox="1"/>
+          <p:nvPr/>
+        </p:nvSpPr>
+        <p:spPr>
+          <a:xfrm>
+            <a:off x="2697480" y="4818888"/>
+            <a:ext cx="2834640" cy="987552"/>
+          </a:xfrm>
+          <a:prstGeom prst="rect">
+            <a:avLst/>
+          </a:prstGeom>
+          <a:noFill/>
+        </p:spPr>
+        <p:txBody>
+          <a:bodyPr wrap="square" anchor="ctr" lIns="25400" rIns="25400" tIns="12700" bIns="12700">
+            <a:spAutoFit/>
+          </a:bodyPr>
+          <a:lstStyle/>
+          <a:p>
+            <a:pPr algn="l">
+              <a:lnSpc>
+                <a:spcPct val="100000"/>
+              </a:lnSpc>
+              <a:spcAft>
+                <a:spcPts val="400"/>
+              </a:spcAft>
+            </a:pPr>
+            <a:r>
+              <a:rPr sz="1400" b="1">
+                <a:solidFill>
+                  <a:srgbClr val="661020"/>
+                </a:solidFill>
+                <a:latin typeface="Calibri"/>
+              </a:rPr>
+              <a:t>Entrega final</a:t>
+            </a:r>
+          </a:p>
+        </p:txBody>
+      </p:sp>
+      <p:sp>
+        <p:nvSpPr>
+          <p:cNvPr id="19" name="TextBox 18"/>
+          <p:cNvSpPr txBox="1"/>
+          <p:nvPr/>
+        </p:nvSpPr>
+        <p:spPr>
+          <a:xfrm>
+            <a:off x="5577840" y="4818888"/>
+            <a:ext cx="6126480" cy="987552"/>
+          </a:xfrm>
+          <a:prstGeom prst="rect">
+            <a:avLst/>
+          </a:prstGeom>
+          <a:noFill/>
+        </p:spPr>
+        <p:txBody>
+          <a:bodyPr wrap="square" anchor="ctr" lIns="25400" rIns="25400" tIns="12700" bIns="12700">
+            <a:spAutoFit/>
+          </a:bodyPr>
+          <a:lstStyle/>
+          <a:p>
+            <a:pPr algn="l">
+              <a:lnSpc>
+                <a:spcPct val="105000"/>
+              </a:lnSpc>
+              <a:spcAft>
+                <a:spcPts val="400"/>
+              </a:spcAft>
+            </a:pPr>
+            <a:r>
+              <a:rPr sz="1250" b="0">
+                <a:solidFill>
+                  <a:srgbClr val="363636"/>
+                </a:solidFill>
+                <a:latin typeface="Calibri"/>
+              </a:rPr>
+              <a:t>Documento completo y defensa</a:t>
+            </a:r>
+          </a:p>
+        </p:txBody>
+      </p:sp>
+    </p:spTree>
+  </p:cSld>
+  <p:clrMapOvr>
+    <a:masterClrMapping/>
+  </p:clrMapOvr>
+</p:sld>
+</file>
+
+<file path=ppt/slides/slide7.xml><?xml version="1.0" encoding="utf-8"?>
+<p:sld xmlns:a="http://schemas.openxmlformats.org/drawingml/2006/main" xmlns:p="http://schemas.openxmlformats.org/presentationml/2006/main" xmlns:r="http://schemas.openxmlformats.org/officeDocument/2006/relationships">
+  <p:cSld>
+    <p:spTree>
+      <p:nvGrpSpPr>
+        <p:cNvPr id="1" name=""/>
+        <p:cNvGrpSpPr/>
+        <p:nvPr/>
+      </p:nvGrpSpPr>
+      <p:grpSpPr/>
+      <p:sp>
+        <p:nvSpPr>
+          <p:cNvPr id="2" name="Rectangle 1"/>
+          <p:cNvSpPr/>
+          <p:nvPr/>
+        </p:nvSpPr>
+        <p:spPr>
+          <a:xfrm>
+            <a:off x="0" y="0"/>
+            <a:ext cx="12191695" cy="6858000"/>
+          </a:xfrm>
+          <a:prstGeom prst="rect">
             <a:avLst/>
           </a:prstGeom>
           <a:solidFill>
@@ -8459,14 +8362,14 @@
       </p:sp>
       <p:sp>
         <p:nvSpPr>
-          <p:cNvPr id="18" name="TextBox 17"/>
+          <p:cNvPr id="3" name="TextBox 2"/>
           <p:cNvSpPr txBox="1"/>
           <p:nvPr/>
         </p:nvSpPr>
         <p:spPr>
           <a:xfrm>
-            <a:off x="640080" y="4178808"/>
-            <a:ext cx="1737360" cy="841248"/>
+            <a:off x="1005840" y="2377440"/>
+            <a:ext cx="10149840" cy="1097280"/>
           </a:xfrm>
           <a:prstGeom prst="rect">
             <a:avLst/>
@@ -8474,7 +8377,7 @@
           <a:noFill/>
         </p:spPr>
         <p:txBody>
-          <a:bodyPr wrap="square" anchor="ctr" lIns="25400" rIns="25400" tIns="12700" bIns="12700">
+          <a:bodyPr wrap="square" anchor="t" lIns="25400" rIns="25400" tIns="12700" bIns="12700">
             <a:spAutoFit/>
           </a:bodyPr>
           <a:lstStyle/>
@@ -8488,113 +8391,29 @@
               </a:spcAft>
             </a:pPr>
             <a:r>
-              <a:rPr sz="1250" b="1">
+              <a:rPr sz="4800" b="1">
                 <a:solidFill>
                   <a:srgbClr val="FFFFFF"/>
                 </a:solidFill>
                 <a:latin typeface="Calibri"/>
               </a:rPr>
-              <a:t>DIC · FEB</a:t>
-            </a:r>
-          </a:p>
-        </p:txBody>
-      </p:sp>
-      <p:sp>
-        <p:nvSpPr>
-          <p:cNvPr id="19" name="TextBox 18"/>
-          <p:cNvSpPr txBox="1"/>
-          <p:nvPr/>
-        </p:nvSpPr>
-        <p:spPr>
-          <a:xfrm>
-            <a:off x="2697480" y="4242816"/>
-            <a:ext cx="2834640" cy="841248"/>
+              <a:t>Gracias</a:t>
+            </a:r>
+          </a:p>
+        </p:txBody>
+      </p:sp>
+      <p:sp>
+        <p:nvSpPr>
+          <p:cNvPr id="4" name="Rectangle 3"/>
+          <p:cNvSpPr/>
+          <p:nvPr/>
+        </p:nvSpPr>
+        <p:spPr>
+          <a:xfrm>
+            <a:off x="5413248" y="3611880"/>
+            <a:ext cx="1371600" cy="50800"/>
           </a:xfrm>
           <a:prstGeom prst="rect">
-            <a:avLst/>
-          </a:prstGeom>
-          <a:noFill/>
-        </p:spPr>
-        <p:txBody>
-          <a:bodyPr wrap="square" anchor="ctr" lIns="25400" rIns="25400" tIns="12700" bIns="12700">
-            <a:spAutoFit/>
-          </a:bodyPr>
-          <a:lstStyle/>
-          <a:p>
-            <a:pPr algn="l">
-              <a:lnSpc>
-                <a:spcPct val="100000"/>
-              </a:lnSpc>
-              <a:spcAft>
-                <a:spcPts val="400"/>
-              </a:spcAft>
-            </a:pPr>
-            <a:r>
-              <a:rPr sz="1400" b="1">
-                <a:solidFill>
-                  <a:srgbClr val="661020"/>
-                </a:solidFill>
-                <a:latin typeface="Calibri"/>
-              </a:rPr>
-              <a:t>Cierre de la memoria</a:t>
-            </a:r>
-          </a:p>
-        </p:txBody>
-      </p:sp>
-      <p:sp>
-        <p:nvSpPr>
-          <p:cNvPr id="20" name="TextBox 19"/>
-          <p:cNvSpPr txBox="1"/>
-          <p:nvPr/>
-        </p:nvSpPr>
-        <p:spPr>
-          <a:xfrm>
-            <a:off x="5577840" y="4242816"/>
-            <a:ext cx="6126480" cy="841248"/>
-          </a:xfrm>
-          <a:prstGeom prst="rect">
-            <a:avLst/>
-          </a:prstGeom>
-          <a:noFill/>
-        </p:spPr>
-        <p:txBody>
-          <a:bodyPr wrap="square" anchor="ctr" lIns="25400" rIns="25400" tIns="12700" bIns="12700">
-            <a:spAutoFit/>
-          </a:bodyPr>
-          <a:lstStyle/>
-          <a:p>
-            <a:pPr algn="l">
-              <a:lnSpc>
-                <a:spcPct val="105000"/>
-              </a:lnSpc>
-              <a:spcAft>
-                <a:spcPts val="400"/>
-              </a:spcAft>
-            </a:pPr>
-            <a:r>
-              <a:rPr sz="1250" b="0">
-                <a:solidFill>
-                  <a:srgbClr val="363636"/>
-                </a:solidFill>
-                <a:latin typeface="Calibri"/>
-              </a:rPr>
-              <a:t>Análisis de resultados, capítulo de la PoC, metodología y conclusiones</a:t>
-            </a:r>
-          </a:p>
-        </p:txBody>
-      </p:sp>
-      <p:sp>
-        <p:nvSpPr>
-          <p:cNvPr id="21" name="Rounded Rectangle 20"/>
-          <p:cNvSpPr/>
-          <p:nvPr/>
-        </p:nvSpPr>
-        <p:spPr>
-          <a:xfrm>
-            <a:off x="640080" y="5129784"/>
-            <a:ext cx="1737360" cy="841248"/>
-          </a:xfrm>
-          <a:prstGeom prst="roundRect">
             <a:avLst/>
           </a:prstGeom>
           <a:solidFill>
@@ -8629,140 +8448,14 @@
       </p:sp>
       <p:sp>
         <p:nvSpPr>
-          <p:cNvPr id="22" name="TextBox 21"/>
+          <p:cNvPr id="5" name="TextBox 4"/>
           <p:cNvSpPr txBox="1"/>
           <p:nvPr/>
         </p:nvSpPr>
         <p:spPr>
           <a:xfrm>
-            <a:off x="640080" y="5129784"/>
-            <a:ext cx="1737360" cy="841248"/>
-          </a:xfrm>
-          <a:prstGeom prst="rect">
-            <a:avLst/>
-          </a:prstGeom>
-          <a:noFill/>
-        </p:spPr>
-        <p:txBody>
-          <a:bodyPr wrap="square" anchor="ctr" lIns="25400" rIns="25400" tIns="12700" bIns="12700">
-            <a:spAutoFit/>
-          </a:bodyPr>
-          <a:lstStyle/>
-          <a:p>
-            <a:pPr algn="ctr">
-              <a:lnSpc>
-                <a:spcPct val="100000"/>
-              </a:lnSpc>
-              <a:spcAft>
-                <a:spcPts val="400"/>
-              </a:spcAft>
-            </a:pPr>
-            <a:r>
-              <a:rPr sz="1250" b="1">
-                <a:solidFill>
-                  <a:srgbClr val="FFFFFF"/>
-                </a:solidFill>
-                <a:latin typeface="Calibri"/>
-              </a:rPr>
-              <a:t>MAR 2027</a:t>
-            </a:r>
-          </a:p>
-        </p:txBody>
-      </p:sp>
-      <p:sp>
-        <p:nvSpPr>
-          <p:cNvPr id="23" name="TextBox 22"/>
-          <p:cNvSpPr txBox="1"/>
-          <p:nvPr/>
-        </p:nvSpPr>
-        <p:spPr>
-          <a:xfrm>
-            <a:off x="2697480" y="5193792"/>
-            <a:ext cx="2834640" cy="841248"/>
-          </a:xfrm>
-          <a:prstGeom prst="rect">
-            <a:avLst/>
-          </a:prstGeom>
-          <a:noFill/>
-        </p:spPr>
-        <p:txBody>
-          <a:bodyPr wrap="square" anchor="ctr" lIns="25400" rIns="25400" tIns="12700" bIns="12700">
-            <a:spAutoFit/>
-          </a:bodyPr>
-          <a:lstStyle/>
-          <a:p>
-            <a:pPr algn="l">
-              <a:lnSpc>
-                <a:spcPct val="100000"/>
-              </a:lnSpc>
-              <a:spcAft>
-                <a:spcPts val="400"/>
-              </a:spcAft>
-            </a:pPr>
-            <a:r>
-              <a:rPr sz="1400" b="1">
-                <a:solidFill>
-                  <a:srgbClr val="661020"/>
-                </a:solidFill>
-                <a:latin typeface="Calibri"/>
-              </a:rPr>
-              <a:t>Entrega final</a:t>
-            </a:r>
-          </a:p>
-        </p:txBody>
-      </p:sp>
-      <p:sp>
-        <p:nvSpPr>
-          <p:cNvPr id="24" name="TextBox 23"/>
-          <p:cNvSpPr txBox="1"/>
-          <p:nvPr/>
-        </p:nvSpPr>
-        <p:spPr>
-          <a:xfrm>
-            <a:off x="5577840" y="5193792"/>
-            <a:ext cx="6126480" cy="841248"/>
-          </a:xfrm>
-          <a:prstGeom prst="rect">
-            <a:avLst/>
-          </a:prstGeom>
-          <a:noFill/>
-        </p:spPr>
-        <p:txBody>
-          <a:bodyPr wrap="square" anchor="ctr" lIns="25400" rIns="25400" tIns="12700" bIns="12700">
-            <a:spAutoFit/>
-          </a:bodyPr>
-          <a:lstStyle/>
-          <a:p>
-            <a:pPr algn="l">
-              <a:lnSpc>
-                <a:spcPct val="105000"/>
-              </a:lnSpc>
-              <a:spcAft>
-                <a:spcPts val="400"/>
-              </a:spcAft>
-            </a:pPr>
-            <a:r>
-              <a:rPr sz="1250" b="0">
-                <a:solidFill>
-                  <a:srgbClr val="363636"/>
-                </a:solidFill>
-                <a:latin typeface="Calibri"/>
-              </a:rPr>
-              <a:t>Documento completo y defensa</a:t>
-            </a:r>
-          </a:p>
-        </p:txBody>
-      </p:sp>
-      <p:sp>
-        <p:nvSpPr>
-          <p:cNvPr id="25" name="TextBox 24"/>
-          <p:cNvSpPr txBox="1"/>
-          <p:nvPr/>
-        </p:nvSpPr>
-        <p:spPr>
-          <a:xfrm>
-            <a:off x="640080" y="6263640"/>
-            <a:ext cx="10972800" cy="411480"/>
+            <a:off x="1005840" y="3931920"/>
+            <a:ext cx="10149840" cy="640080"/>
           </a:xfrm>
           <a:prstGeom prst="rect">
             <a:avLst/>
@@ -8775,7 +8468,7 @@
           </a:bodyPr>
           <a:lstStyle/>
           <a:p>
-            <a:pPr algn="l">
+            <a:pPr algn="ctr">
               <a:lnSpc>
                 <a:spcPct val="100000"/>
               </a:lnSpc>
@@ -8784,13 +8477,55 @@
               </a:spcAft>
             </a:pPr>
             <a:r>
-              <a:rPr sz="1150" b="0" i="1">
-                <a:solidFill>
-                  <a:srgbClr val="6B6B6B"/>
-                </a:solidFill>
-                <a:latin typeface="Calibri"/>
-              </a:rPr>
-              <a:t>A acordar con el tutor: mecanismo de consulta de la documentación y diseño fino de la validación de la PoC</a:t>
+              <a:rPr sz="2200" b="0">
+                <a:solidFill>
+                  <a:srgbClr val="EDEAE2"/>
+                </a:solidFill>
+                <a:latin typeface="Calibri"/>
+              </a:rPr>
+              <a:t>¿Preguntas?</a:t>
+            </a:r>
+          </a:p>
+        </p:txBody>
+      </p:sp>
+      <p:sp>
+        <p:nvSpPr>
+          <p:cNvPr id="6" name="TextBox 5"/>
+          <p:cNvSpPr txBox="1"/>
+          <p:nvPr/>
+        </p:nvSpPr>
+        <p:spPr>
+          <a:xfrm>
+            <a:off x="1005840" y="5989320"/>
+            <a:ext cx="10149840" cy="457200"/>
+          </a:xfrm>
+          <a:prstGeom prst="rect">
+            <a:avLst/>
+          </a:prstGeom>
+          <a:noFill/>
+        </p:spPr>
+        <p:txBody>
+          <a:bodyPr wrap="square" anchor="t" lIns="25400" rIns="25400" tIns="12700" bIns="12700">
+            <a:spAutoFit/>
+          </a:bodyPr>
+          <a:lstStyle/>
+          <a:p>
+            <a:pPr algn="ctr">
+              <a:lnSpc>
+                <a:spcPct val="100000"/>
+              </a:lnSpc>
+              <a:spcAft>
+                <a:spcPts val="400"/>
+              </a:spcAft>
+            </a:pPr>
+            <a:r>
+              <a:rPr sz="1200" b="0">
+                <a:solidFill>
+                  <a:srgbClr val="DDD8D4"/>
+                </a:solidFill>
+                <a:latin typeface="Calibri"/>
+              </a:rPr>
+              <a:t>María Victoria Chappuis Adorni · Universidad ORT Uruguay</a:t>
             </a:r>
           </a:p>
         </p:txBody>

</xml_diff>